<commit_message>
feat: increase typography and card readability for presentation slides
</commit_message>
<xml_diff>
--- a/docs/presentation_slides.pptx
+++ b/docs/presentation_slides.pptx
@@ -4413,8 +4413,8 @@
         </p:nvSpPr>
         <p:spPr>
           <a:xfrm>
-            <a:off x="731520" y="822960"/>
-            <a:ext cx="4754880" cy="384048"/>
+            <a:off x="731520" y="731520"/>
+            <a:ext cx="5120640" cy="411480"/>
           </a:xfrm>
           <a:prstGeom prst="roundRect">
             <a:avLst/>
@@ -4443,11 +4443,11 @@
           </a:fontRef>
         </p:style>
         <p:txBody>
-          <a:bodyPr rtlCol="0" anchor="ctr"/>
+          <a:bodyPr rtlCol="0" anchor="ctr" tIns="54864"/>
           <a:lstStyle/>
           <a:p>
             <a:pPr algn="ctr">
-              <a:defRPr sz="1000" b="1">
+              <a:defRPr sz="1100" b="1">
                 <a:solidFill>
                   <a:srgbClr val="34D399"/>
                 </a:solidFill>
@@ -4467,7 +4467,7 @@
         </p:nvSpPr>
         <p:spPr>
           <a:xfrm>
-            <a:off x="731520" y="1371600"/>
+            <a:off x="731520" y="1280160"/>
             <a:ext cx="10698480" cy="1828800"/>
           </a:xfrm>
           <a:prstGeom prst="rect">
@@ -4482,7 +4482,7 @@
           <a:lstStyle/>
           <a:p>
             <a:pPr>
-              <a:defRPr sz="3600" b="1">
+              <a:defRPr sz="3700" b="1">
                 <a:solidFill>
                   <a:srgbClr val="FFFFFF"/>
                 </a:solidFill>
@@ -4506,7 +4506,7 @@
         </p:nvSpPr>
         <p:spPr>
           <a:xfrm>
-            <a:off x="731520" y="3383280"/>
+            <a:off x="731520" y="3337560"/>
             <a:ext cx="10698480" cy="731520"/>
           </a:xfrm>
           <a:prstGeom prst="rect">
@@ -4521,14 +4521,14 @@
           <a:lstStyle/>
           <a:p>
             <a:pPr>
-              <a:defRPr sz="1400">
+              <a:defRPr sz="1500">
                 <a:solidFill>
                   <a:srgbClr val="38BDF8"/>
                 </a:solidFill>
               </a:defRPr>
             </a:pPr>
             <a:r>
-              <a:t>Eliminating Double-Bookings, Customer No-Shows &amp; Revenue Leakage via Deterministic State Machine Automation</a:t>
+              <a:t>Eliminating Double-Bookings, Customer No-Shows &amp; Revenue Leakage via Deterministic State Automation</a:t>
             </a:r>
           </a:p>
         </p:txBody>
@@ -4542,7 +4542,7 @@
         <p:spPr>
           <a:xfrm>
             <a:off x="731520" y="4297680"/>
-            <a:ext cx="4114800" cy="1828800"/>
+            <a:ext cx="4114800" cy="1920240"/>
           </a:xfrm>
           <a:prstGeom prst="roundRect">
             <a:avLst/>
@@ -4571,11 +4571,11 @@
           </a:fontRef>
         </p:style>
         <p:txBody>
-          <a:bodyPr rtlCol="0" anchor="ctr" tIns="182880" lIns="228600"/>
+          <a:bodyPr rtlCol="0" anchor="ctr" tIns="182880" lIns="274320"/>
           <a:lstStyle/>
           <a:p>
             <a:pPr algn="ctr">
-              <a:defRPr sz="1000" b="1">
+              <a:defRPr sz="1100" b="1">
                 <a:solidFill>
                   <a:srgbClr val="34D399"/>
                 </a:solidFill>
@@ -4590,7 +4590,7 @@
               <a:spcBef>
                 <a:spcPts val="400"/>
               </a:spcBef>
-              <a:defRPr sz="1500" b="1">
+              <a:defRPr sz="1600" b="1">
                 <a:solidFill>
                   <a:srgbClr val="FFFFFF"/>
                 </a:solidFill>
@@ -4605,9 +4605,9 @@
               <a:spcBef>
                 <a:spcPts val="400"/>
               </a:spcBef>
-              <a:defRPr sz="1050">
-                <a:solidFill>
-                  <a:srgbClr val="94A3B8"/>
+              <a:defRPr sz="1200">
+                <a:solidFill>
+                  <a:srgbClr val="A0AFC3"/>
                 </a:solidFill>
               </a:defRPr>
             </a:pPr>
@@ -4616,7 +4616,7 @@
             </a:r>
             <a:br/>
             <a:r>
-              <a:t>Department of Computer Science, AIUB</a:t>
+              <a:t>Dept. of Computer Science, AIUB</a:t>
             </a:r>
           </a:p>
         </p:txBody>
@@ -4630,7 +4630,7 @@
         <p:spPr>
           <a:xfrm>
             <a:off x="5120640" y="4297680"/>
-            <a:ext cx="6309360" cy="1828800"/>
+            <a:ext cx="6309360" cy="1920240"/>
           </a:xfrm>
           <a:prstGeom prst="roundRect">
             <a:avLst/>
@@ -4659,11 +4659,11 @@
           </a:fontRef>
         </p:style>
         <p:txBody>
-          <a:bodyPr rtlCol="0" anchor="ctr" tIns="182880" lIns="228600"/>
+          <a:bodyPr rtlCol="0" anchor="ctr" tIns="182880" lIns="274320"/>
           <a:lstStyle/>
           <a:p>
             <a:pPr algn="ctr">
-              <a:defRPr sz="1000" b="1">
+              <a:defRPr sz="1100" b="1">
                 <a:solidFill>
                   <a:srgbClr val="38BDF8"/>
                 </a:solidFill>
@@ -4676,9 +4676,9 @@
           <a:p>
             <a:pPr>
               <a:spcBef>
-                <a:spcPts val="200"/>
+                <a:spcPts val="250"/>
               </a:spcBef>
-              <a:defRPr sz="1100">
+              <a:defRPr sz="1250">
                 <a:solidFill>
                   <a:srgbClr val="F1F5F9"/>
                 </a:solidFill>
@@ -4691,9 +4691,9 @@
           <a:p>
             <a:pPr>
               <a:spcBef>
-                <a:spcPts val="200"/>
+                <a:spcPts val="250"/>
               </a:spcBef>
-              <a:defRPr sz="1100">
+              <a:defRPr sz="1250">
                 <a:solidFill>
                   <a:srgbClr val="F1F5F9"/>
                 </a:solidFill>
@@ -4706,9 +4706,9 @@
           <a:p>
             <a:pPr>
               <a:spcBef>
-                <a:spcPts val="200"/>
+                <a:spcPts val="250"/>
               </a:spcBef>
-              <a:defRPr sz="1100">
+              <a:defRPr sz="1250">
                 <a:solidFill>
                   <a:srgbClr val="F1F5F9"/>
                 </a:solidFill>
@@ -4721,9 +4721,9 @@
           <a:p>
             <a:pPr>
               <a:spcBef>
-                <a:spcPts val="200"/>
+                <a:spcPts val="250"/>
               </a:spcBef>
-              <a:defRPr sz="1100">
+              <a:defRPr sz="1250">
                 <a:solidFill>
                   <a:srgbClr val="F1F5F9"/>
                 </a:solidFill>
@@ -4809,8 +4809,8 @@
         </p:nvSpPr>
         <p:spPr>
           <a:xfrm>
-            <a:off x="731520" y="365760"/>
-            <a:ext cx="5943600" cy="292608"/>
+            <a:off x="731520" y="320040"/>
+            <a:ext cx="6217920" cy="320040"/>
           </a:xfrm>
           <a:prstGeom prst="roundRect">
             <a:avLst/>
@@ -4839,11 +4839,11 @@
           </a:fontRef>
         </p:style>
         <p:txBody>
-          <a:bodyPr rtlCol="0" anchor="ctr" tIns="18288" lIns="137160"/>
+          <a:bodyPr rtlCol="0" anchor="ctr" tIns="36576" lIns="164592"/>
           <a:lstStyle/>
           <a:p>
             <a:pPr algn="ctr">
-              <a:defRPr sz="950" b="1">
+              <a:defRPr sz="1050" b="1">
                 <a:solidFill>
                   <a:srgbClr val="34D399"/>
                 </a:solidFill>
@@ -4863,8 +4863,8 @@
         </p:nvSpPr>
         <p:spPr>
           <a:xfrm>
-            <a:off x="731520" y="685800"/>
-            <a:ext cx="9601200" cy="731520"/>
+            <a:off x="731520" y="658368"/>
+            <a:ext cx="9601200" cy="777240"/>
           </a:xfrm>
           <a:prstGeom prst="rect">
             <a:avLst/>
@@ -4878,7 +4878,7 @@
           <a:lstStyle/>
           <a:p>
             <a:pPr>
-              <a:defRPr sz="2200" b="1">
+              <a:defRPr sz="2300" b="1">
                 <a:solidFill>
                   <a:srgbClr val="FFFFFF"/>
                 </a:solidFill>
@@ -4898,8 +4898,8 @@
         </p:nvSpPr>
         <p:spPr>
           <a:xfrm>
-            <a:off x="10607040" y="365760"/>
-            <a:ext cx="822960" cy="292608"/>
+            <a:off x="10515600" y="320040"/>
+            <a:ext cx="914400" cy="320040"/>
           </a:xfrm>
           <a:prstGeom prst="roundRect">
             <a:avLst/>
@@ -4928,13 +4928,13 @@
           </a:fontRef>
         </p:style>
         <p:txBody>
-          <a:bodyPr rtlCol="0" anchor="ctr" tIns="18288"/>
+          <a:bodyPr rtlCol="0" anchor="ctr" tIns="36576"/>
           <a:lstStyle/>
           <a:p>
             <a:pPr algn="ctr">
-              <a:defRPr sz="1000" b="1">
-                <a:solidFill>
-                  <a:srgbClr val="94A3B8"/>
+              <a:defRPr sz="1100" b="1">
+                <a:solidFill>
+                  <a:srgbClr val="A0AFC3"/>
                 </a:solidFill>
               </a:defRPr>
             </a:pPr>
@@ -4952,8 +4952,8 @@
         </p:nvSpPr>
         <p:spPr>
           <a:xfrm>
-            <a:off x="731520" y="1645920"/>
-            <a:ext cx="5166360" cy="4389120"/>
+            <a:off x="731520" y="1600200"/>
+            <a:ext cx="5166360" cy="4480560"/>
           </a:xfrm>
           <a:prstGeom prst="roundRect">
             <a:avLst/>
@@ -4982,11 +4982,11 @@
           </a:fontRef>
         </p:style>
         <p:txBody>
-          <a:bodyPr rtlCol="0" anchor="ctr" lIns="274320" tIns="274320"/>
+          <a:bodyPr rtlCol="0" anchor="ctr" lIns="320040" tIns="274320"/>
           <a:lstStyle/>
           <a:p>
             <a:pPr algn="ctr">
-              <a:defRPr sz="1400" b="1">
+              <a:defRPr sz="1650" b="1">
                 <a:solidFill>
                   <a:srgbClr val="34D399"/>
                 </a:solidFill>
@@ -4999,9 +4999,9 @@
           <a:p>
             <a:pPr>
               <a:spcBef>
-                <a:spcPts val="1000"/>
+                <a:spcPts val="1200"/>
               </a:spcBef>
-              <a:defRPr sz="1100">
+              <a:defRPr sz="1300">
                 <a:solidFill>
                   <a:srgbClr val="F1F5F9"/>
                 </a:solidFill>
@@ -5037,8 +5037,8 @@
         </p:nvSpPr>
         <p:spPr>
           <a:xfrm>
-            <a:off x="6217920" y="1645920"/>
-            <a:ext cx="5212080" cy="4389120"/>
+            <a:off x="6217920" y="1600200"/>
+            <a:ext cx="5212080" cy="4480560"/>
           </a:xfrm>
           <a:prstGeom prst="roundRect">
             <a:avLst/>
@@ -5067,11 +5067,11 @@
           </a:fontRef>
         </p:style>
         <p:txBody>
-          <a:bodyPr rtlCol="0" anchor="ctr" lIns="274320" tIns="274320"/>
+          <a:bodyPr rtlCol="0" anchor="ctr" lIns="320040" tIns="274320"/>
           <a:lstStyle/>
           <a:p>
             <a:pPr algn="ctr">
-              <a:defRPr sz="1400" b="1">
+              <a:defRPr sz="1650" b="1">
                 <a:solidFill>
                   <a:srgbClr val="FBBF24"/>
                 </a:solidFill>
@@ -5084,9 +5084,9 @@
           <a:p>
             <a:pPr>
               <a:spcBef>
-                <a:spcPts val="1000"/>
+                <a:spcPts val="1200"/>
               </a:spcBef>
-              <a:defRPr sz="1100">
+              <a:defRPr sz="1300">
                 <a:solidFill>
                   <a:srgbClr val="F1F5F9"/>
                 </a:solidFill>
@@ -5109,7 +5109,7 @@
             </a:r>
             <a:br/>
             <a:r>
-              <a:t>• Customer Feedback CSAT Rating (4.9 / 5.0 ★ • 98% Satisfaction)</a:t>
+              <a:t>• Customer Feedback CSAT Rating (4.9 / 5.0 ★ • 98% CSAT)</a:t>
             </a:r>
           </a:p>
         </p:txBody>
@@ -5188,8 +5188,8 @@
         </p:nvSpPr>
         <p:spPr>
           <a:xfrm>
-            <a:off x="731520" y="365760"/>
-            <a:ext cx="5943600" cy="292608"/>
+            <a:off x="731520" y="320040"/>
+            <a:ext cx="6217920" cy="320040"/>
           </a:xfrm>
           <a:prstGeom prst="roundRect">
             <a:avLst/>
@@ -5218,11 +5218,11 @@
           </a:fontRef>
         </p:style>
         <p:txBody>
-          <a:bodyPr rtlCol="0" anchor="ctr" tIns="18288" lIns="137160"/>
+          <a:bodyPr rtlCol="0" anchor="ctr" tIns="36576" lIns="164592"/>
           <a:lstStyle/>
           <a:p>
             <a:pPr algn="ctr">
-              <a:defRPr sz="950" b="1">
+              <a:defRPr sz="1050" b="1">
                 <a:solidFill>
                   <a:srgbClr val="34D399"/>
                 </a:solidFill>
@@ -5242,8 +5242,8 @@
         </p:nvSpPr>
         <p:spPr>
           <a:xfrm>
-            <a:off x="731520" y="685800"/>
-            <a:ext cx="9601200" cy="731520"/>
+            <a:off x="731520" y="658368"/>
+            <a:ext cx="9601200" cy="777240"/>
           </a:xfrm>
           <a:prstGeom prst="rect">
             <a:avLst/>
@@ -5257,7 +5257,7 @@
           <a:lstStyle/>
           <a:p>
             <a:pPr>
-              <a:defRPr sz="2200" b="1">
+              <a:defRPr sz="2300" b="1">
                 <a:solidFill>
                   <a:srgbClr val="FFFFFF"/>
                 </a:solidFill>
@@ -5277,8 +5277,8 @@
         </p:nvSpPr>
         <p:spPr>
           <a:xfrm>
-            <a:off x="10607040" y="365760"/>
-            <a:ext cx="822960" cy="292608"/>
+            <a:off x="10515600" y="320040"/>
+            <a:ext cx="914400" cy="320040"/>
           </a:xfrm>
           <a:prstGeom prst="roundRect">
             <a:avLst/>
@@ -5307,13 +5307,13 @@
           </a:fontRef>
         </p:style>
         <p:txBody>
-          <a:bodyPr rtlCol="0" anchor="ctr" tIns="18288"/>
+          <a:bodyPr rtlCol="0" anchor="ctr" tIns="36576"/>
           <a:lstStyle/>
           <a:p>
             <a:pPr algn="ctr">
-              <a:defRPr sz="1000" b="1">
-                <a:solidFill>
-                  <a:srgbClr val="94A3B8"/>
+              <a:defRPr sz="1100" b="1">
+                <a:solidFill>
+                  <a:srgbClr val="A0AFC3"/>
                 </a:solidFill>
               </a:defRPr>
             </a:pPr>
@@ -5331,8 +5331,8 @@
         </p:nvSpPr>
         <p:spPr>
           <a:xfrm>
-            <a:off x="731520" y="1645920"/>
-            <a:ext cx="10698480" cy="731520"/>
+            <a:off x="731520" y="1600200"/>
+            <a:ext cx="10698480" cy="777240"/>
           </a:xfrm>
           <a:prstGeom prst="roundRect">
             <a:avLst/>
@@ -5361,11 +5361,11 @@
           </a:fontRef>
         </p:style>
         <p:txBody>
-          <a:bodyPr rtlCol="0" anchor="ctr" lIns="228600" tIns="137160"/>
+          <a:bodyPr rtlCol="0" anchor="ctr" lIns="274320" tIns="146304"/>
           <a:lstStyle/>
           <a:p>
             <a:pPr algn="ctr">
-              <a:defRPr sz="1100" b="1">
+              <a:defRPr sz="1350" b="1">
                 <a:solidFill>
                   <a:srgbClr val="38BDF8"/>
                 </a:solidFill>
@@ -5377,7 +5377,7 @@
           </a:p>
           <a:p>
             <a:pPr>
-              <a:defRPr sz="1050">
+              <a:defRPr sz="1200">
                 <a:solidFill>
                   <a:srgbClr val="F1F5F9"/>
                 </a:solidFill>
@@ -5397,8 +5397,8 @@
         </p:nvSpPr>
         <p:spPr>
           <a:xfrm>
-            <a:off x="731520" y="2514600"/>
-            <a:ext cx="10698480" cy="731520"/>
+            <a:off x="731520" y="2496312"/>
+            <a:ext cx="10698480" cy="777240"/>
           </a:xfrm>
           <a:prstGeom prst="roundRect">
             <a:avLst/>
@@ -5427,11 +5427,11 @@
           </a:fontRef>
         </p:style>
         <p:txBody>
-          <a:bodyPr rtlCol="0" anchor="ctr" lIns="228600" tIns="137160"/>
+          <a:bodyPr rtlCol="0" anchor="ctr" lIns="274320" tIns="146304"/>
           <a:lstStyle/>
           <a:p>
             <a:pPr algn="ctr">
-              <a:defRPr sz="1100" b="1">
+              <a:defRPr sz="1350" b="1">
                 <a:solidFill>
                   <a:srgbClr val="34D399"/>
                 </a:solidFill>
@@ -5443,7 +5443,7 @@
           </a:p>
           <a:p>
             <a:pPr>
-              <a:defRPr sz="1050">
+              <a:defRPr sz="1200">
                 <a:solidFill>
                   <a:srgbClr val="F1F5F9"/>
                 </a:solidFill>
@@ -5463,8 +5463,8 @@
         </p:nvSpPr>
         <p:spPr>
           <a:xfrm>
-            <a:off x="731520" y="3383280"/>
-            <a:ext cx="10698480" cy="731520"/>
+            <a:off x="731520" y="3392424"/>
+            <a:ext cx="10698480" cy="777240"/>
           </a:xfrm>
           <a:prstGeom prst="roundRect">
             <a:avLst/>
@@ -5493,11 +5493,11 @@
           </a:fontRef>
         </p:style>
         <p:txBody>
-          <a:bodyPr rtlCol="0" anchor="ctr" lIns="228600" tIns="137160"/>
+          <a:bodyPr rtlCol="0" anchor="ctr" lIns="274320" tIns="146304"/>
           <a:lstStyle/>
           <a:p>
             <a:pPr algn="ctr">
-              <a:defRPr sz="1100" b="1">
+              <a:defRPr sz="1350" b="1">
                 <a:solidFill>
                   <a:srgbClr val="C084FC"/>
                 </a:solidFill>
@@ -5509,7 +5509,7 @@
           </a:p>
           <a:p>
             <a:pPr>
-              <a:defRPr sz="1050">
+              <a:defRPr sz="1200">
                 <a:solidFill>
                   <a:srgbClr val="F1F5F9"/>
                 </a:solidFill>
@@ -5529,8 +5529,8 @@
         </p:nvSpPr>
         <p:spPr>
           <a:xfrm>
-            <a:off x="731520" y="4251959"/>
-            <a:ext cx="10698480" cy="731520"/>
+            <a:off x="731520" y="4288536"/>
+            <a:ext cx="10698480" cy="777240"/>
           </a:xfrm>
           <a:prstGeom prst="roundRect">
             <a:avLst/>
@@ -5559,11 +5559,11 @@
           </a:fontRef>
         </p:style>
         <p:txBody>
-          <a:bodyPr rtlCol="0" anchor="ctr" lIns="228600" tIns="137160"/>
+          <a:bodyPr rtlCol="0" anchor="ctr" lIns="274320" tIns="146304"/>
           <a:lstStyle/>
           <a:p>
             <a:pPr algn="ctr">
-              <a:defRPr sz="1100" b="1">
+              <a:defRPr sz="1350" b="1">
                 <a:solidFill>
                   <a:srgbClr val="FBBF24"/>
                 </a:solidFill>
@@ -5575,7 +5575,7 @@
           </a:p>
           <a:p>
             <a:pPr>
-              <a:defRPr sz="1050">
+              <a:defRPr sz="1200">
                 <a:solidFill>
                   <a:srgbClr val="F1F5F9"/>
                 </a:solidFill>
@@ -5595,8 +5595,8 @@
         </p:nvSpPr>
         <p:spPr>
           <a:xfrm>
-            <a:off x="731520" y="5120640"/>
-            <a:ext cx="10698480" cy="731520"/>
+            <a:off x="731520" y="5184648"/>
+            <a:ext cx="10698480" cy="777240"/>
           </a:xfrm>
           <a:prstGeom prst="roundRect">
             <a:avLst/>
@@ -5625,11 +5625,11 @@
           </a:fontRef>
         </p:style>
         <p:txBody>
-          <a:bodyPr rtlCol="0" anchor="ctr" lIns="228600" tIns="137160"/>
+          <a:bodyPr rtlCol="0" anchor="ctr" lIns="274320" tIns="146304"/>
           <a:lstStyle/>
           <a:p>
             <a:pPr algn="ctr">
-              <a:defRPr sz="1100" b="1">
+              <a:defRPr sz="1350" b="1">
                 <a:solidFill>
                   <a:srgbClr val="34D399"/>
                 </a:solidFill>
@@ -5641,7 +5641,7 @@
           </a:p>
           <a:p>
             <a:pPr>
-              <a:defRPr sz="1050">
+              <a:defRPr sz="1200">
                 <a:solidFill>
                   <a:srgbClr val="F1F5F9"/>
                 </a:solidFill>
@@ -5727,8 +5727,8 @@
         </p:nvSpPr>
         <p:spPr>
           <a:xfrm>
-            <a:off x="731520" y="365760"/>
-            <a:ext cx="5943600" cy="292608"/>
+            <a:off x="731520" y="320040"/>
+            <a:ext cx="6217920" cy="320040"/>
           </a:xfrm>
           <a:prstGeom prst="roundRect">
             <a:avLst/>
@@ -5757,11 +5757,11 @@
           </a:fontRef>
         </p:style>
         <p:txBody>
-          <a:bodyPr rtlCol="0" anchor="ctr" tIns="18288" lIns="137160"/>
+          <a:bodyPr rtlCol="0" anchor="ctr" tIns="36576" lIns="164592"/>
           <a:lstStyle/>
           <a:p>
             <a:pPr algn="ctr">
-              <a:defRPr sz="950" b="1">
+              <a:defRPr sz="1050" b="1">
                 <a:solidFill>
                   <a:srgbClr val="34D399"/>
                 </a:solidFill>
@@ -5781,8 +5781,8 @@
         </p:nvSpPr>
         <p:spPr>
           <a:xfrm>
-            <a:off x="731520" y="685800"/>
-            <a:ext cx="9601200" cy="731520"/>
+            <a:off x="731520" y="658368"/>
+            <a:ext cx="9601200" cy="777240"/>
           </a:xfrm>
           <a:prstGeom prst="rect">
             <a:avLst/>
@@ -5796,7 +5796,7 @@
           <a:lstStyle/>
           <a:p>
             <a:pPr>
-              <a:defRPr sz="2200" b="1">
+              <a:defRPr sz="2300" b="1">
                 <a:solidFill>
                   <a:srgbClr val="FFFFFF"/>
                 </a:solidFill>
@@ -5816,8 +5816,8 @@
         </p:nvSpPr>
         <p:spPr>
           <a:xfrm>
-            <a:off x="10607040" y="365760"/>
-            <a:ext cx="822960" cy="292608"/>
+            <a:off x="10515600" y="320040"/>
+            <a:ext cx="914400" cy="320040"/>
           </a:xfrm>
           <a:prstGeom prst="roundRect">
             <a:avLst/>
@@ -5846,13 +5846,13 @@
           </a:fontRef>
         </p:style>
         <p:txBody>
-          <a:bodyPr rtlCol="0" anchor="ctr" tIns="18288"/>
+          <a:bodyPr rtlCol="0" anchor="ctr" tIns="36576"/>
           <a:lstStyle/>
           <a:p>
             <a:pPr algn="ctr">
-              <a:defRPr sz="1000" b="1">
-                <a:solidFill>
-                  <a:srgbClr val="94A3B8"/>
+              <a:defRPr sz="1100" b="1">
+                <a:solidFill>
+                  <a:srgbClr val="A0AFC3"/>
                 </a:solidFill>
               </a:defRPr>
             </a:pPr>
@@ -5870,8 +5870,8 @@
         </p:nvSpPr>
         <p:spPr>
           <a:xfrm>
-            <a:off x="731520" y="1645920"/>
-            <a:ext cx="2514600" cy="4389120"/>
+            <a:off x="731520" y="1600200"/>
+            <a:ext cx="2514600" cy="4480560"/>
           </a:xfrm>
           <a:prstGeom prst="roundRect">
             <a:avLst/>
@@ -5904,7 +5904,7 @@
           <a:lstStyle/>
           <a:p>
             <a:pPr algn="ctr">
-              <a:defRPr sz="1300" b="1">
+              <a:defRPr sz="1600" b="1">
                 <a:solidFill>
                   <a:srgbClr val="38BDF8"/>
                 </a:solidFill>
@@ -5919,7 +5919,7 @@
               <a:spcBef>
                 <a:spcPts val="1200"/>
               </a:spcBef>
-              <a:defRPr sz="1050">
+              <a:defRPr sz="1250">
                 <a:solidFill>
                   <a:srgbClr val="F1F5F9"/>
                 </a:solidFill>
@@ -5934,11 +5934,11 @@
             </a:r>
             <a:br/>
             <a:r>
-              <a:t>• TailwindCSS &amp; Lucide Icons</a:t>
+              <a:t>• TailwindCSS &amp; Lucide</a:t>
             </a:r>
             <a:br/>
             <a:r>
-              <a:t>• Responsive 390px Mobile View</a:t>
+              <a:t>• 390px Mobile View</a:t>
             </a:r>
           </a:p>
         </p:txBody>
@@ -5951,8 +5951,8 @@
         </p:nvSpPr>
         <p:spPr>
           <a:xfrm>
-            <a:off x="3429000" y="1645920"/>
-            <a:ext cx="2514600" cy="4389120"/>
+            <a:off x="3429000" y="1600200"/>
+            <a:ext cx="2514600" cy="4480560"/>
           </a:xfrm>
           <a:prstGeom prst="roundRect">
             <a:avLst/>
@@ -5985,7 +5985,7 @@
           <a:lstStyle/>
           <a:p>
             <a:pPr algn="ctr">
-              <a:defRPr sz="1300" b="1">
+              <a:defRPr sz="1600" b="1">
                 <a:solidFill>
                   <a:srgbClr val="C084FC"/>
                 </a:solidFill>
@@ -6000,18 +6000,18 @@
               <a:spcBef>
                 <a:spcPts val="1200"/>
               </a:spcBef>
-              <a:defRPr sz="1050">
+              <a:defRPr sz="1250">
                 <a:solidFill>
                   <a:srgbClr val="F1F5F9"/>
                 </a:solidFill>
               </a:defRPr>
             </a:pPr>
             <a:r>
-              <a:t>• PostgreSQL / Supabase Schema</a:t>
+              <a:t>• PostgreSQL Schema DDL</a:t>
             </a:r>
             <a:br/>
             <a:r>
-              <a:t>• Finite State Machine Engine</a:t>
+              <a:t>• Finite State Machine</a:t>
             </a:r>
             <a:br/>
             <a:r>
@@ -6032,8 +6032,8 @@
         </p:nvSpPr>
         <p:spPr>
           <a:xfrm>
-            <a:off x="6126480" y="1645920"/>
-            <a:ext cx="2514600" cy="4389120"/>
+            <a:off x="6126480" y="1600200"/>
+            <a:ext cx="2514600" cy="4480560"/>
           </a:xfrm>
           <a:prstGeom prst="roundRect">
             <a:avLst/>
@@ -6066,14 +6066,14 @@
           <a:lstStyle/>
           <a:p>
             <a:pPr algn="ctr">
-              <a:defRPr sz="1300" b="1">
+              <a:defRPr sz="1600" b="1">
                 <a:solidFill>
                   <a:srgbClr val="FBBF24"/>
                 </a:solidFill>
               </a:defRPr>
             </a:pPr>
             <a:r>
-              <a:t>State Management</a:t>
+              <a:t>State &amp; Store</a:t>
             </a:r>
           </a:p>
           <a:p>
@@ -6081,14 +6081,14 @@
               <a:spcBef>
                 <a:spcPts val="1200"/>
               </a:spcBef>
-              <a:defRPr sz="1050">
+              <a:defRPr sz="1250">
                 <a:solidFill>
                   <a:srgbClr val="F1F5F9"/>
                 </a:solidFill>
               </a:defRPr>
             </a:pPr>
             <a:r>
-              <a:t>• Reactive Context Store (store.tsx)</a:t>
+              <a:t>• Reactive Context Store</a:t>
             </a:r>
             <a:br/>
             <a:r>
@@ -6096,11 +6096,11 @@
             </a:r>
             <a:br/>
             <a:r>
-              <a:t>• Zero third-party runtime failure</a:t>
+              <a:t>• Zero 3rd-Party Failure</a:t>
             </a:r>
             <a:br/>
             <a:r>
-              <a:t>• Offline &amp; Vercel ready</a:t>
+              <a:t>• Offline / Vercel ready</a:t>
             </a:r>
           </a:p>
         </p:txBody>
@@ -6113,8 +6113,8 @@
         </p:nvSpPr>
         <p:spPr>
           <a:xfrm>
-            <a:off x="8823960" y="1645920"/>
-            <a:ext cx="2514600" cy="4389120"/>
+            <a:off x="8823960" y="1600200"/>
+            <a:ext cx="2514600" cy="4480560"/>
           </a:xfrm>
           <a:prstGeom prst="roundRect">
             <a:avLst/>
@@ -6147,14 +6147,14 @@
           <a:lstStyle/>
           <a:p>
             <a:pPr algn="ctr">
-              <a:defRPr sz="1300" b="1">
+              <a:defRPr sz="1600" b="1">
                 <a:solidFill>
                   <a:srgbClr val="34D399"/>
                 </a:solidFill>
               </a:defRPr>
             </a:pPr>
             <a:r>
-              <a:t>Production Verification</a:t>
+              <a:t>Verification</a:t>
             </a:r>
           </a:p>
           <a:p>
@@ -6162,7 +6162,7 @@
               <a:spcBef>
                 <a:spcPts val="1200"/>
               </a:spcBef>
-              <a:defRPr sz="1050">
+              <a:defRPr sz="1250">
                 <a:solidFill>
                   <a:srgbClr val="F1F5F9"/>
                 </a:solidFill>
@@ -6181,7 +6181,7 @@
             </a:r>
             <a:br/>
             <a:r>
-              <a:t>• Pushed to GitHub (main)</a:t>
+              <a:t>• GitHub main branch synced</a:t>
             </a:r>
           </a:p>
         </p:txBody>
@@ -6260,8 +6260,8 @@
         </p:nvSpPr>
         <p:spPr>
           <a:xfrm>
-            <a:off x="731520" y="1097280"/>
-            <a:ext cx="3474720" cy="365760"/>
+            <a:off x="731520" y="1005840"/>
+            <a:ext cx="3840480" cy="384048"/>
           </a:xfrm>
           <a:prstGeom prst="roundRect">
             <a:avLst/>
@@ -6290,11 +6290,11 @@
           </a:fontRef>
         </p:style>
         <p:txBody>
-          <a:bodyPr rtlCol="0" anchor="ctr"/>
+          <a:bodyPr rtlCol="0" anchor="ctr" tIns="54864"/>
           <a:lstStyle/>
           <a:p>
             <a:pPr algn="ctr">
-              <a:defRPr sz="950" b="1">
+              <a:defRPr sz="1100" b="1">
                 <a:solidFill>
                   <a:srgbClr val="34D399"/>
                 </a:solidFill>
@@ -6314,8 +6314,8 @@
         </p:nvSpPr>
         <p:spPr>
           <a:xfrm>
-            <a:off x="731520" y="1645920"/>
-            <a:ext cx="10698480" cy="1371600"/>
+            <a:off x="731520" y="1554480"/>
+            <a:ext cx="10698480" cy="1463040"/>
           </a:xfrm>
           <a:prstGeom prst="rect">
             <a:avLst/>
@@ -6329,7 +6329,7 @@
           <a:lstStyle/>
           <a:p>
             <a:pPr>
-              <a:defRPr sz="3800" b="1">
+              <a:defRPr sz="3900" b="1">
                 <a:solidFill>
                   <a:srgbClr val="FFFFFF"/>
                 </a:solidFill>
@@ -6353,8 +6353,8 @@
         </p:nvSpPr>
         <p:spPr>
           <a:xfrm>
-            <a:off x="731520" y="3474720"/>
-            <a:ext cx="10698480" cy="2560320"/>
+            <a:off x="731520" y="3429000"/>
+            <a:ext cx="10698480" cy="2651760"/>
           </a:xfrm>
           <a:prstGeom prst="roundRect">
             <a:avLst/>
@@ -6383,11 +6383,11 @@
           </a:fontRef>
         </p:style>
         <p:txBody>
-          <a:bodyPr rtlCol="0" anchor="ctr" lIns="274320" tIns="228600"/>
+          <a:bodyPr rtlCol="0" anchor="ctr" lIns="320040" tIns="256032"/>
           <a:lstStyle/>
           <a:p>
             <a:pPr algn="ctr">
-              <a:defRPr sz="1100" b="1">
+              <a:defRPr sz="1300" b="1">
                 <a:solidFill>
                   <a:srgbClr val="38BDF8"/>
                 </a:solidFill>
@@ -6400,9 +6400,9 @@
           <a:p>
             <a:pPr>
               <a:spcBef>
-                <a:spcPts val="400"/>
+                <a:spcPts val="500"/>
               </a:spcBef>
-              <a:defRPr sz="1150">
+              <a:defRPr sz="1350">
                 <a:solidFill>
                   <a:srgbClr val="F1F5F9"/>
                 </a:solidFill>
@@ -6415,46 +6415,46 @@
           <a:p>
             <a:pPr>
               <a:spcBef>
-                <a:spcPts val="400"/>
+                <a:spcPts val="500"/>
               </a:spcBef>
-              <a:defRPr sz="1150">
+              <a:defRPr sz="1350">
                 <a:solidFill>
                   <a:srgbClr val="F1F5F9"/>
                 </a:solidFill>
               </a:defRPr>
             </a:pPr>
             <a:r>
-              <a:t>✔ Successfully eliminates double-bookings, customer no-shows, and revenue leakage.</a:t>
+              <a:t>✔ Successfully eliminates double-bookings, customer no-shows, and manual revenue leakage.</a:t>
             </a:r>
           </a:p>
           <a:p>
             <a:pPr>
               <a:spcBef>
-                <a:spcPts val="400"/>
+                <a:spcPts val="500"/>
               </a:spcBef>
-              <a:defRPr sz="1150">
+              <a:defRPr sz="1350">
                 <a:solidFill>
                   <a:srgbClr val="F1F5F9"/>
                 </a:solidFill>
               </a:defRPr>
             </a:pPr>
             <a:r>
-              <a:t>✔ Developed iteratively following Agile Scrum across 4 two-week sprint milestones.</a:t>
+              <a:t>✔ Developed iteratively following Agile Scrum framework across 4 two-week sprint milestones.</a:t>
             </a:r>
           </a:p>
           <a:p>
             <a:pPr>
               <a:spcBef>
-                <a:spcPts val="400"/>
+                <a:spcPts val="500"/>
               </a:spcBef>
-              <a:defRPr sz="1150">
+              <a:defRPr sz="1350">
                 <a:solidFill>
                   <a:srgbClr val="F1F5F9"/>
                 </a:solidFill>
               </a:defRPr>
             </a:pPr>
             <a:r>
-              <a:t>✔ Fully deployable on Vercel with zero external database setup barriers.</a:t>
+              <a:t>✔ Production-verified and deployable on Vercel with zero external database barriers.</a:t>
             </a:r>
           </a:p>
         </p:txBody>
@@ -6533,8 +6533,8 @@
         </p:nvSpPr>
         <p:spPr>
           <a:xfrm>
-            <a:off x="731520" y="365760"/>
-            <a:ext cx="5943600" cy="292608"/>
+            <a:off x="731520" y="320040"/>
+            <a:ext cx="6217920" cy="320040"/>
           </a:xfrm>
           <a:prstGeom prst="roundRect">
             <a:avLst/>
@@ -6563,11 +6563,11 @@
           </a:fontRef>
         </p:style>
         <p:txBody>
-          <a:bodyPr rtlCol="0" anchor="ctr" tIns="18288" lIns="137160"/>
+          <a:bodyPr rtlCol="0" anchor="ctr" tIns="36576" lIns="164592"/>
           <a:lstStyle/>
           <a:p>
             <a:pPr algn="ctr">
-              <a:defRPr sz="950" b="1">
+              <a:defRPr sz="1050" b="1">
                 <a:solidFill>
                   <a:srgbClr val="34D399"/>
                 </a:solidFill>
@@ -6587,8 +6587,8 @@
         </p:nvSpPr>
         <p:spPr>
           <a:xfrm>
-            <a:off x="731520" y="685800"/>
-            <a:ext cx="9601200" cy="731520"/>
+            <a:off x="731520" y="658368"/>
+            <a:ext cx="9601200" cy="777240"/>
           </a:xfrm>
           <a:prstGeom prst="rect">
             <a:avLst/>
@@ -6602,7 +6602,7 @@
           <a:lstStyle/>
           <a:p>
             <a:pPr>
-              <a:defRPr sz="2200" b="1">
+              <a:defRPr sz="2300" b="1">
                 <a:solidFill>
                   <a:srgbClr val="FFFFFF"/>
                 </a:solidFill>
@@ -6622,8 +6622,8 @@
         </p:nvSpPr>
         <p:spPr>
           <a:xfrm>
-            <a:off x="10607040" y="365760"/>
-            <a:ext cx="822960" cy="292608"/>
+            <a:off x="10515600" y="320040"/>
+            <a:ext cx="914400" cy="320040"/>
           </a:xfrm>
           <a:prstGeom prst="roundRect">
             <a:avLst/>
@@ -6652,13 +6652,13 @@
           </a:fontRef>
         </p:style>
         <p:txBody>
-          <a:bodyPr rtlCol="0" anchor="ctr" tIns="18288"/>
+          <a:bodyPr rtlCol="0" anchor="ctr" tIns="36576"/>
           <a:lstStyle/>
           <a:p>
             <a:pPr algn="ctr">
-              <a:defRPr sz="1000" b="1">
-                <a:solidFill>
-                  <a:srgbClr val="94A3B8"/>
+              <a:defRPr sz="1100" b="1">
+                <a:solidFill>
+                  <a:srgbClr val="A0AFC3"/>
                 </a:solidFill>
               </a:defRPr>
             </a:pPr>
@@ -6676,8 +6676,8 @@
         </p:nvSpPr>
         <p:spPr>
           <a:xfrm>
-            <a:off x="731520" y="1645920"/>
-            <a:ext cx="5166360" cy="2057400"/>
+            <a:off x="731520" y="1600200"/>
+            <a:ext cx="5166360" cy="2148840"/>
           </a:xfrm>
           <a:prstGeom prst="roundRect">
             <a:avLst/>
@@ -6706,11 +6706,11 @@
           </a:fontRef>
         </p:style>
         <p:txBody>
-          <a:bodyPr rtlCol="0" anchor="ctr" lIns="274320" tIns="228600" rIns="274320"/>
+          <a:bodyPr rtlCol="0" anchor="ctr" lIns="320040" tIns="228600" rIns="320040"/>
           <a:lstStyle/>
           <a:p>
             <a:pPr algn="ctr">
-              <a:defRPr sz="950" b="1">
+              <a:defRPr sz="1100" b="1">
                 <a:solidFill>
                   <a:srgbClr val="FB7185"/>
                 </a:solidFill>
@@ -6725,24 +6725,24 @@
               <a:spcBef>
                 <a:spcPts val="300"/>
               </a:spcBef>
-              <a:defRPr sz="1350" b="1">
+              <a:defRPr sz="1550" b="1">
                 <a:solidFill>
                   <a:srgbClr val="FFFFFF"/>
                 </a:solidFill>
               </a:defRPr>
             </a:pPr>
             <a:r>
-              <a:t>Double-Booking &amp; Scheduling Collisions</a:t>
+              <a:t>Double-Booking &amp; Schedule Collisions</a:t>
             </a:r>
           </a:p>
           <a:p>
             <a:pPr>
               <a:spcBef>
-                <a:spcPts val="600"/>
+                <a:spcPts val="700"/>
               </a:spcBef>
-              <a:defRPr sz="1050">
-                <a:solidFill>
-                  <a:srgbClr val="94A3B8"/>
+              <a:defRPr sz="1250">
+                <a:solidFill>
+                  <a:srgbClr val="F1F5F9"/>
                 </a:solidFill>
               </a:defRPr>
             </a:pPr>
@@ -6760,8 +6760,8 @@
         </p:nvSpPr>
         <p:spPr>
           <a:xfrm>
-            <a:off x="6172200" y="1645920"/>
-            <a:ext cx="5166360" cy="2057400"/>
+            <a:off x="6172200" y="1600200"/>
+            <a:ext cx="5166360" cy="2148840"/>
           </a:xfrm>
           <a:prstGeom prst="roundRect">
             <a:avLst/>
@@ -6790,11 +6790,11 @@
           </a:fontRef>
         </p:style>
         <p:txBody>
-          <a:bodyPr rtlCol="0" anchor="ctr" lIns="274320" tIns="228600" rIns="274320"/>
+          <a:bodyPr rtlCol="0" anchor="ctr" lIns="320040" tIns="228600" rIns="320040"/>
           <a:lstStyle/>
           <a:p>
             <a:pPr algn="ctr">
-              <a:defRPr sz="950" b="1">
+              <a:defRPr sz="1100" b="1">
                 <a:solidFill>
                   <a:srgbClr val="FBBF24"/>
                 </a:solidFill>
@@ -6809,7 +6809,7 @@
               <a:spcBef>
                 <a:spcPts val="300"/>
               </a:spcBef>
-              <a:defRPr sz="1350" b="1">
+              <a:defRPr sz="1550" b="1">
                 <a:solidFill>
                   <a:srgbClr val="FFFFFF"/>
                 </a:solidFill>
@@ -6822,11 +6822,11 @@
           <a:p>
             <a:pPr>
               <a:spcBef>
-                <a:spcPts val="600"/>
+                <a:spcPts val="700"/>
               </a:spcBef>
-              <a:defRPr sz="1050">
-                <a:solidFill>
-                  <a:srgbClr val="94A3B8"/>
+              <a:defRPr sz="1250">
+                <a:solidFill>
+                  <a:srgbClr val="F1F5F9"/>
                 </a:solidFill>
               </a:defRPr>
             </a:pPr>
@@ -6844,8 +6844,8 @@
         </p:nvSpPr>
         <p:spPr>
           <a:xfrm>
-            <a:off x="731520" y="3931920"/>
-            <a:ext cx="5166360" cy="2057400"/>
+            <a:off x="731520" y="3977639"/>
+            <a:ext cx="5166360" cy="2148840"/>
           </a:xfrm>
           <a:prstGeom prst="roundRect">
             <a:avLst/>
@@ -6874,11 +6874,11 @@
           </a:fontRef>
         </p:style>
         <p:txBody>
-          <a:bodyPr rtlCol="0" anchor="ctr" lIns="274320" tIns="228600" rIns="274320"/>
+          <a:bodyPr rtlCol="0" anchor="ctr" lIns="320040" tIns="228600" rIns="320040"/>
           <a:lstStyle/>
           <a:p>
             <a:pPr algn="ctr">
-              <a:defRPr sz="950" b="1">
+              <a:defRPr sz="1100" b="1">
                 <a:solidFill>
                   <a:srgbClr val="38BDF8"/>
                 </a:solidFill>
@@ -6893,7 +6893,7 @@
               <a:spcBef>
                 <a:spcPts val="300"/>
               </a:spcBef>
-              <a:defRPr sz="1350" b="1">
+              <a:defRPr sz="1550" b="1">
                 <a:solidFill>
                   <a:srgbClr val="FFFFFF"/>
                 </a:solidFill>
@@ -6906,11 +6906,11 @@
           <a:p>
             <a:pPr>
               <a:spcBef>
-                <a:spcPts val="600"/>
+                <a:spcPts val="700"/>
               </a:spcBef>
-              <a:defRPr sz="1050">
-                <a:solidFill>
-                  <a:srgbClr val="94A3B8"/>
+              <a:defRPr sz="1250">
+                <a:solidFill>
+                  <a:srgbClr val="F1F5F9"/>
                 </a:solidFill>
               </a:defRPr>
             </a:pPr>
@@ -6928,8 +6928,8 @@
         </p:nvSpPr>
         <p:spPr>
           <a:xfrm>
-            <a:off x="6172200" y="3931920"/>
-            <a:ext cx="5166360" cy="2057400"/>
+            <a:off x="6172200" y="3977639"/>
+            <a:ext cx="5166360" cy="2148840"/>
           </a:xfrm>
           <a:prstGeom prst="roundRect">
             <a:avLst/>
@@ -6958,11 +6958,11 @@
           </a:fontRef>
         </p:style>
         <p:txBody>
-          <a:bodyPr rtlCol="0" anchor="ctr" lIns="274320" tIns="228600" rIns="274320"/>
+          <a:bodyPr rtlCol="0" anchor="ctr" lIns="320040" tIns="228600" rIns="320040"/>
           <a:lstStyle/>
           <a:p>
             <a:pPr algn="ctr">
-              <a:defRPr sz="950" b="1">
+              <a:defRPr sz="1100" b="1">
                 <a:solidFill>
                   <a:srgbClr val="C084FC"/>
                 </a:solidFill>
@@ -6977,7 +6977,7 @@
               <a:spcBef>
                 <a:spcPts val="300"/>
               </a:spcBef>
-              <a:defRPr sz="1350" b="1">
+              <a:defRPr sz="1550" b="1">
                 <a:solidFill>
                   <a:srgbClr val="FFFFFF"/>
                 </a:solidFill>
@@ -6990,16 +6990,16 @@
           <a:p>
             <a:pPr>
               <a:spcBef>
-                <a:spcPts val="600"/>
+                <a:spcPts val="700"/>
               </a:spcBef>
-              <a:defRPr sz="1050">
-                <a:solidFill>
-                  <a:srgbClr val="94A3B8"/>
-                </a:solidFill>
-              </a:defRPr>
-            </a:pPr>
-            <a:r>
-              <a:t>Delayed paper billing, unrecorded cash balances, and lack of verifiable proof-of-work lead to disputed invoices and lost revenue.</a:t>
+              <a:defRPr sz="1250">
+                <a:solidFill>
+                  <a:srgbClr val="F1F5F9"/>
+                </a:solidFill>
+              </a:defRPr>
+            </a:pPr>
+            <a:r>
+              <a:t>Delayed paper billing, unrecorded cash balances, and lack of verified proof-of-work lead to disputed invoices and lost revenue.</a:t>
             </a:r>
           </a:p>
         </p:txBody>
@@ -7078,8 +7078,8 @@
         </p:nvSpPr>
         <p:spPr>
           <a:xfrm>
-            <a:off x="731520" y="365760"/>
-            <a:ext cx="5943600" cy="292608"/>
+            <a:off x="731520" y="320040"/>
+            <a:ext cx="6217920" cy="320040"/>
           </a:xfrm>
           <a:prstGeom prst="roundRect">
             <a:avLst/>
@@ -7108,11 +7108,11 @@
           </a:fontRef>
         </p:style>
         <p:txBody>
-          <a:bodyPr rtlCol="0" anchor="ctr" tIns="18288" lIns="137160"/>
+          <a:bodyPr rtlCol="0" anchor="ctr" tIns="36576" lIns="164592"/>
           <a:lstStyle/>
           <a:p>
             <a:pPr algn="ctr">
-              <a:defRPr sz="950" b="1">
+              <a:defRPr sz="1050" b="1">
                 <a:solidFill>
                   <a:srgbClr val="34D399"/>
                 </a:solidFill>
@@ -7132,8 +7132,8 @@
         </p:nvSpPr>
         <p:spPr>
           <a:xfrm>
-            <a:off x="731520" y="685800"/>
-            <a:ext cx="9601200" cy="731520"/>
+            <a:off x="731520" y="658368"/>
+            <a:ext cx="9601200" cy="777240"/>
           </a:xfrm>
           <a:prstGeom prst="rect">
             <a:avLst/>
@@ -7147,7 +7147,7 @@
           <a:lstStyle/>
           <a:p>
             <a:pPr>
-              <a:defRPr sz="2200" b="1">
+              <a:defRPr sz="2300" b="1">
                 <a:solidFill>
                   <a:srgbClr val="FFFFFF"/>
                 </a:solidFill>
@@ -7167,8 +7167,8 @@
         </p:nvSpPr>
         <p:spPr>
           <a:xfrm>
-            <a:off x="10607040" y="365760"/>
-            <a:ext cx="822960" cy="292608"/>
+            <a:off x="10515600" y="320040"/>
+            <a:ext cx="914400" cy="320040"/>
           </a:xfrm>
           <a:prstGeom prst="roundRect">
             <a:avLst/>
@@ -7197,13 +7197,13 @@
           </a:fontRef>
         </p:style>
         <p:txBody>
-          <a:bodyPr rtlCol="0" anchor="ctr" tIns="18288"/>
+          <a:bodyPr rtlCol="0" anchor="ctr" tIns="36576"/>
           <a:lstStyle/>
           <a:p>
             <a:pPr algn="ctr">
-              <a:defRPr sz="1000" b="1">
-                <a:solidFill>
-                  <a:srgbClr val="94A3B8"/>
+              <a:defRPr sz="1100" b="1">
+                <a:solidFill>
+                  <a:srgbClr val="A0AFC3"/>
                 </a:solidFill>
               </a:defRPr>
             </a:pPr>
@@ -7221,8 +7221,8 @@
         </p:nvSpPr>
         <p:spPr>
           <a:xfrm>
-            <a:off x="731520" y="1645920"/>
-            <a:ext cx="3429000" cy="4389120"/>
+            <a:off x="731520" y="1600200"/>
+            <a:ext cx="3429000" cy="4480560"/>
           </a:xfrm>
           <a:prstGeom prst="roundRect">
             <a:avLst/>
@@ -7251,11 +7251,11 @@
           </a:fontRef>
         </p:style>
         <p:txBody>
-          <a:bodyPr rtlCol="0" anchor="ctr" lIns="274320" tIns="274320" rIns="274320"/>
+          <a:bodyPr rtlCol="0" anchor="ctr" lIns="320040" tIns="274320" rIns="320040"/>
           <a:lstStyle/>
           <a:p>
             <a:pPr algn="ctr">
-              <a:defRPr sz="950" b="1">
+              <a:defRPr sz="1100" b="1">
                 <a:solidFill>
                   <a:srgbClr val="34D399"/>
                 </a:solidFill>
@@ -7270,7 +7270,7 @@
               <a:spcBef>
                 <a:spcPts val="400"/>
               </a:spcBef>
-              <a:defRPr sz="1400" b="1">
+              <a:defRPr sz="1650" b="1">
                 <a:solidFill>
                   <a:srgbClr val="FFFFFF"/>
                 </a:solidFill>
@@ -7283,9 +7283,9 @@
           <a:p>
             <a:pPr>
               <a:spcBef>
-                <a:spcPts val="1200"/>
+                <a:spcPts val="1400"/>
               </a:spcBef>
-              <a:defRPr sz="1100">
+              <a:defRPr sz="1300">
                 <a:solidFill>
                   <a:srgbClr val="F1F5F9"/>
                 </a:solidFill>
@@ -7300,11 +7300,11 @@
             </a:r>
             <a:br/>
             <a:r>
-              <a:t>• 20% upfront deposit checkout (bKash/Nagad)</a:t>
+              <a:t>• 20% upfront deposit checkout (bKash)</a:t>
             </a:r>
             <a:br/>
             <a:r>
-              <a:t>• Real-time progress &amp; SMS notification feed</a:t>
+              <a:t>• Real-time progress &amp; SMS alert stream</a:t>
             </a:r>
           </a:p>
         </p:txBody>
@@ -7317,8 +7317,8 @@
         </p:nvSpPr>
         <p:spPr>
           <a:xfrm>
-            <a:off x="4343400" y="1645920"/>
-            <a:ext cx="3429000" cy="4389120"/>
+            <a:off x="4343400" y="1600200"/>
+            <a:ext cx="3429000" cy="4480560"/>
           </a:xfrm>
           <a:prstGeom prst="roundRect">
             <a:avLst/>
@@ -7347,11 +7347,11 @@
           </a:fontRef>
         </p:style>
         <p:txBody>
-          <a:bodyPr rtlCol="0" anchor="ctr" lIns="274320" tIns="274320" rIns="274320"/>
+          <a:bodyPr rtlCol="0" anchor="ctr" lIns="320040" tIns="274320" rIns="320040"/>
           <a:lstStyle/>
           <a:p>
             <a:pPr algn="ctr">
-              <a:defRPr sz="950" b="1">
+              <a:defRPr sz="1100" b="1">
                 <a:solidFill>
                   <a:srgbClr val="C084FC"/>
                 </a:solidFill>
@@ -7366,7 +7366,7 @@
               <a:spcBef>
                 <a:spcPts val="400"/>
               </a:spcBef>
-              <a:defRPr sz="1400" b="1">
+              <a:defRPr sz="1650" b="1">
                 <a:solidFill>
                   <a:srgbClr val="FFFFFF"/>
                 </a:solidFill>
@@ -7379,9 +7379,9 @@
           <a:p>
             <a:pPr>
               <a:spcBef>
-                <a:spcPts val="1200"/>
+                <a:spcPts val="1400"/>
               </a:spcBef>
-              <a:defRPr sz="1100">
+              <a:defRPr sz="1300">
                 <a:solidFill>
                   <a:srgbClr val="F1F5F9"/>
                 </a:solidFill>
@@ -7413,8 +7413,8 @@
         </p:nvSpPr>
         <p:spPr>
           <a:xfrm>
-            <a:off x="7955280" y="1645920"/>
-            <a:ext cx="3429000" cy="4389120"/>
+            <a:off x="7955280" y="1600200"/>
+            <a:ext cx="3429000" cy="4480560"/>
           </a:xfrm>
           <a:prstGeom prst="roundRect">
             <a:avLst/>
@@ -7443,11 +7443,11 @@
           </a:fontRef>
         </p:style>
         <p:txBody>
-          <a:bodyPr rtlCol="0" anchor="ctr" lIns="274320" tIns="274320" rIns="274320"/>
+          <a:bodyPr rtlCol="0" anchor="ctr" lIns="320040" tIns="274320" rIns="320040"/>
           <a:lstStyle/>
           <a:p>
             <a:pPr algn="ctr">
-              <a:defRPr sz="950" b="1">
+              <a:defRPr sz="1100" b="1">
                 <a:solidFill>
                   <a:srgbClr val="38BDF8"/>
                 </a:solidFill>
@@ -7462,7 +7462,7 @@
               <a:spcBef>
                 <a:spcPts val="400"/>
               </a:spcBef>
-              <a:defRPr sz="1400" b="1">
+              <a:defRPr sz="1650" b="1">
                 <a:solidFill>
                   <a:srgbClr val="FFFFFF"/>
                 </a:solidFill>
@@ -7475,9 +7475,9 @@
           <a:p>
             <a:pPr>
               <a:spcBef>
-                <a:spcPts val="1200"/>
+                <a:spcPts val="1400"/>
               </a:spcBef>
-              <a:defRPr sz="1100">
+              <a:defRPr sz="1300">
                 <a:solidFill>
                   <a:srgbClr val="F1F5F9"/>
                 </a:solidFill>
@@ -7575,8 +7575,8 @@
         </p:nvSpPr>
         <p:spPr>
           <a:xfrm>
-            <a:off x="731520" y="365760"/>
-            <a:ext cx="5943600" cy="292608"/>
+            <a:off x="731520" y="320040"/>
+            <a:ext cx="6217920" cy="320040"/>
           </a:xfrm>
           <a:prstGeom prst="roundRect">
             <a:avLst/>
@@ -7605,11 +7605,11 @@
           </a:fontRef>
         </p:style>
         <p:txBody>
-          <a:bodyPr rtlCol="0" anchor="ctr" tIns="18288" lIns="137160"/>
+          <a:bodyPr rtlCol="0" anchor="ctr" tIns="36576" lIns="164592"/>
           <a:lstStyle/>
           <a:p>
             <a:pPr algn="ctr">
-              <a:defRPr sz="950" b="1">
+              <a:defRPr sz="1050" b="1">
                 <a:solidFill>
                   <a:srgbClr val="34D399"/>
                 </a:solidFill>
@@ -7629,8 +7629,8 @@
         </p:nvSpPr>
         <p:spPr>
           <a:xfrm>
-            <a:off x="731520" y="685800"/>
-            <a:ext cx="9601200" cy="731520"/>
+            <a:off x="731520" y="658368"/>
+            <a:ext cx="9601200" cy="777240"/>
           </a:xfrm>
           <a:prstGeom prst="rect">
             <a:avLst/>
@@ -7644,7 +7644,7 @@
           <a:lstStyle/>
           <a:p>
             <a:pPr>
-              <a:defRPr sz="2200" b="1">
+              <a:defRPr sz="2300" b="1">
                 <a:solidFill>
                   <a:srgbClr val="FFFFFF"/>
                 </a:solidFill>
@@ -7664,8 +7664,8 @@
         </p:nvSpPr>
         <p:spPr>
           <a:xfrm>
-            <a:off x="10607040" y="365760"/>
-            <a:ext cx="822960" cy="292608"/>
+            <a:off x="10515600" y="320040"/>
+            <a:ext cx="914400" cy="320040"/>
           </a:xfrm>
           <a:prstGeom prst="roundRect">
             <a:avLst/>
@@ -7694,13 +7694,13 @@
           </a:fontRef>
         </p:style>
         <p:txBody>
-          <a:bodyPr rtlCol="0" anchor="ctr" tIns="18288"/>
+          <a:bodyPr rtlCol="0" anchor="ctr" tIns="36576"/>
           <a:lstStyle/>
           <a:p>
             <a:pPr algn="ctr">
-              <a:defRPr sz="1000" b="1">
-                <a:solidFill>
-                  <a:srgbClr val="94A3B8"/>
+              <a:defRPr sz="1100" b="1">
+                <a:solidFill>
+                  <a:srgbClr val="A0AFC3"/>
                 </a:solidFill>
               </a:defRPr>
             </a:pPr>
@@ -7718,8 +7718,8 @@
         </p:nvSpPr>
         <p:spPr>
           <a:xfrm>
-            <a:off x="731520" y="1645920"/>
-            <a:ext cx="5166360" cy="2057400"/>
+            <a:off x="731520" y="1600200"/>
+            <a:ext cx="5166360" cy="2148840"/>
           </a:xfrm>
           <a:prstGeom prst="roundRect">
             <a:avLst/>
@@ -7748,11 +7748,11 @@
           </a:fontRef>
         </p:style>
         <p:txBody>
-          <a:bodyPr rtlCol="0" anchor="ctr" lIns="274320" tIns="201168" rIns="274320"/>
+          <a:bodyPr rtlCol="0" anchor="ctr" lIns="320040" tIns="201168" rIns="320040"/>
           <a:lstStyle/>
           <a:p>
             <a:pPr algn="ctr">
-              <a:defRPr sz="950" b="1">
+              <a:defRPr sz="1100" b="1">
                 <a:solidFill>
                   <a:srgbClr val="38BDF8"/>
                 </a:solidFill>
@@ -7767,7 +7767,7 @@
               <a:spcBef>
                 <a:spcPts val="300"/>
               </a:spcBef>
-              <a:defRPr sz="1350" b="1">
+              <a:defRPr sz="1550" b="1">
                 <a:solidFill>
                   <a:srgbClr val="FFFFFF"/>
                 </a:solidFill>
@@ -7780,9 +7780,9 @@
           <a:p>
             <a:pPr>
               <a:spcBef>
-                <a:spcPts val="500"/>
+                <a:spcPts val="600"/>
               </a:spcBef>
-              <a:defRPr sz="1000">
+              <a:defRPr sz="1200">
                 <a:solidFill>
                   <a:srgbClr val="F1F5F9"/>
                 </a:solidFill>
@@ -7814,8 +7814,8 @@
         </p:nvSpPr>
         <p:spPr>
           <a:xfrm>
-            <a:off x="6172200" y="1645920"/>
-            <a:ext cx="5166360" cy="2057400"/>
+            <a:off x="6172200" y="1600200"/>
+            <a:ext cx="5166360" cy="2148840"/>
           </a:xfrm>
           <a:prstGeom prst="roundRect">
             <a:avLst/>
@@ -7844,11 +7844,11 @@
           </a:fontRef>
         </p:style>
         <p:txBody>
-          <a:bodyPr rtlCol="0" anchor="ctr" lIns="274320" tIns="201168" rIns="274320"/>
+          <a:bodyPr rtlCol="0" anchor="ctr" lIns="320040" tIns="201168" rIns="320040"/>
           <a:lstStyle/>
           <a:p>
             <a:pPr algn="ctr">
-              <a:defRPr sz="950" b="1">
+              <a:defRPr sz="1100" b="1">
                 <a:solidFill>
                   <a:srgbClr val="34D399"/>
                 </a:solidFill>
@@ -7863,7 +7863,7 @@
               <a:spcBef>
                 <a:spcPts val="300"/>
               </a:spcBef>
-              <a:defRPr sz="1350" b="1">
+              <a:defRPr sz="1550" b="1">
                 <a:solidFill>
                   <a:srgbClr val="FFFFFF"/>
                 </a:solidFill>
@@ -7876,9 +7876,9 @@
           <a:p>
             <a:pPr>
               <a:spcBef>
-                <a:spcPts val="500"/>
+                <a:spcPts val="600"/>
               </a:spcBef>
-              <a:defRPr sz="1000">
+              <a:defRPr sz="1200">
                 <a:solidFill>
                   <a:srgbClr val="F1F5F9"/>
                 </a:solidFill>
@@ -7910,8 +7910,8 @@
         </p:nvSpPr>
         <p:spPr>
           <a:xfrm>
-            <a:off x="731520" y="3931920"/>
-            <a:ext cx="5166360" cy="2057400"/>
+            <a:off x="731520" y="3977639"/>
+            <a:ext cx="5166360" cy="2148840"/>
           </a:xfrm>
           <a:prstGeom prst="roundRect">
             <a:avLst/>
@@ -7940,11 +7940,11 @@
           </a:fontRef>
         </p:style>
         <p:txBody>
-          <a:bodyPr rtlCol="0" anchor="ctr" lIns="274320" tIns="201168" rIns="274320"/>
+          <a:bodyPr rtlCol="0" anchor="ctr" lIns="320040" tIns="201168" rIns="320040"/>
           <a:lstStyle/>
           <a:p>
             <a:pPr algn="ctr">
-              <a:defRPr sz="950" b="1">
+              <a:defRPr sz="1100" b="1">
                 <a:solidFill>
                   <a:srgbClr val="C084FC"/>
                 </a:solidFill>
@@ -7959,7 +7959,7 @@
               <a:spcBef>
                 <a:spcPts val="300"/>
               </a:spcBef>
-              <a:defRPr sz="1350" b="1">
+              <a:defRPr sz="1550" b="1">
                 <a:solidFill>
                   <a:srgbClr val="FFFFFF"/>
                 </a:solidFill>
@@ -7972,9 +7972,9 @@
           <a:p>
             <a:pPr>
               <a:spcBef>
-                <a:spcPts val="500"/>
+                <a:spcPts val="600"/>
               </a:spcBef>
-              <a:defRPr sz="1000">
+              <a:defRPr sz="1200">
                 <a:solidFill>
                   <a:srgbClr val="F1F5F9"/>
                 </a:solidFill>
@@ -8006,8 +8006,8 @@
         </p:nvSpPr>
         <p:spPr>
           <a:xfrm>
-            <a:off x="6172200" y="3931920"/>
-            <a:ext cx="5166360" cy="2057400"/>
+            <a:off x="6172200" y="3977639"/>
+            <a:ext cx="5166360" cy="2148840"/>
           </a:xfrm>
           <a:prstGeom prst="roundRect">
             <a:avLst/>
@@ -8036,11 +8036,11 @@
           </a:fontRef>
         </p:style>
         <p:txBody>
-          <a:bodyPr rtlCol="0" anchor="ctr" lIns="274320" tIns="201168" rIns="274320"/>
+          <a:bodyPr rtlCol="0" anchor="ctr" lIns="320040" tIns="201168" rIns="320040"/>
           <a:lstStyle/>
           <a:p>
             <a:pPr algn="ctr">
-              <a:defRPr sz="950" b="1">
+              <a:defRPr sz="1100" b="1">
                 <a:solidFill>
                   <a:srgbClr val="FBBF24"/>
                 </a:solidFill>
@@ -8055,7 +8055,7 @@
               <a:spcBef>
                 <a:spcPts val="300"/>
               </a:spcBef>
-              <a:defRPr sz="1350" b="1">
+              <a:defRPr sz="1550" b="1">
                 <a:solidFill>
                   <a:srgbClr val="FFFFFF"/>
                 </a:solidFill>
@@ -8068,9 +8068,9 @@
           <a:p>
             <a:pPr>
               <a:spcBef>
-                <a:spcPts val="500"/>
+                <a:spcPts val="600"/>
               </a:spcBef>
-              <a:defRPr sz="1000">
+              <a:defRPr sz="1200">
                 <a:solidFill>
                   <a:srgbClr val="F1F5F9"/>
                 </a:solidFill>
@@ -8168,8 +8168,8 @@
         </p:nvSpPr>
         <p:spPr>
           <a:xfrm>
-            <a:off x="731520" y="365760"/>
-            <a:ext cx="5943600" cy="292608"/>
+            <a:off x="731520" y="320040"/>
+            <a:ext cx="6217920" cy="320040"/>
           </a:xfrm>
           <a:prstGeom prst="roundRect">
             <a:avLst/>
@@ -8198,11 +8198,11 @@
           </a:fontRef>
         </p:style>
         <p:txBody>
-          <a:bodyPr rtlCol="0" anchor="ctr" tIns="18288" lIns="137160"/>
+          <a:bodyPr rtlCol="0" anchor="ctr" tIns="36576" lIns="164592"/>
           <a:lstStyle/>
           <a:p>
             <a:pPr algn="ctr">
-              <a:defRPr sz="950" b="1">
+              <a:defRPr sz="1050" b="1">
                 <a:solidFill>
                   <a:srgbClr val="34D399"/>
                 </a:solidFill>
@@ -8222,8 +8222,8 @@
         </p:nvSpPr>
         <p:spPr>
           <a:xfrm>
-            <a:off x="731520" y="685800"/>
-            <a:ext cx="9601200" cy="731520"/>
+            <a:off x="731520" y="658368"/>
+            <a:ext cx="9601200" cy="777240"/>
           </a:xfrm>
           <a:prstGeom prst="rect">
             <a:avLst/>
@@ -8237,7 +8237,7 @@
           <a:lstStyle/>
           <a:p>
             <a:pPr>
-              <a:defRPr sz="2200" b="1">
+              <a:defRPr sz="2300" b="1">
                 <a:solidFill>
                   <a:srgbClr val="FFFFFF"/>
                 </a:solidFill>
@@ -8257,8 +8257,8 @@
         </p:nvSpPr>
         <p:spPr>
           <a:xfrm>
-            <a:off x="10607040" y="365760"/>
-            <a:ext cx="822960" cy="292608"/>
+            <a:off x="10515600" y="320040"/>
+            <a:ext cx="914400" cy="320040"/>
           </a:xfrm>
           <a:prstGeom prst="roundRect">
             <a:avLst/>
@@ -8287,13 +8287,13 @@
           </a:fontRef>
         </p:style>
         <p:txBody>
-          <a:bodyPr rtlCol="0" anchor="ctr" tIns="18288"/>
+          <a:bodyPr rtlCol="0" anchor="ctr" tIns="36576"/>
           <a:lstStyle/>
           <a:p>
             <a:pPr algn="ctr">
-              <a:defRPr sz="1000" b="1">
-                <a:solidFill>
-                  <a:srgbClr val="94A3B8"/>
+              <a:defRPr sz="1100" b="1">
+                <a:solidFill>
+                  <a:srgbClr val="A0AFC3"/>
                 </a:solidFill>
               </a:defRPr>
             </a:pPr>
@@ -8311,8 +8311,8 @@
         </p:nvSpPr>
         <p:spPr>
           <a:xfrm>
-            <a:off x="731520" y="1645920"/>
-            <a:ext cx="2514600" cy="4389120"/>
+            <a:off x="731520" y="1600200"/>
+            <a:ext cx="2514600" cy="4480560"/>
           </a:xfrm>
           <a:prstGeom prst="roundRect">
             <a:avLst/>
@@ -8345,7 +8345,7 @@
           <a:lstStyle/>
           <a:p>
             <a:pPr algn="ctr">
-              <a:defRPr sz="2000" b="1">
+              <a:defRPr sz="2400" b="1">
                 <a:solidFill>
                   <a:srgbClr val="34D399"/>
                 </a:solidFill>
@@ -8360,7 +8360,7 @@
               <a:spcBef>
                 <a:spcPts val="800"/>
               </a:spcBef>
-              <a:defRPr sz="1400" b="1">
+              <a:defRPr sz="1600" b="1">
                 <a:solidFill>
                   <a:srgbClr val="FFFFFF"/>
                 </a:solidFill>
@@ -8375,7 +8375,7 @@
               <a:spcBef>
                 <a:spcPts val="1200"/>
               </a:spcBef>
-              <a:defRPr sz="1100">
+              <a:defRPr sz="1250">
                 <a:solidFill>
                   <a:srgbClr val="F1F5F9"/>
                 </a:solidFill>
@@ -8395,8 +8395,8 @@
         </p:nvSpPr>
         <p:spPr>
           <a:xfrm>
-            <a:off x="3429000" y="1645920"/>
-            <a:ext cx="2514600" cy="4389120"/>
+            <a:off x="3429000" y="1600200"/>
+            <a:ext cx="2514600" cy="4480560"/>
           </a:xfrm>
           <a:prstGeom prst="roundRect">
             <a:avLst/>
@@ -8429,7 +8429,7 @@
           <a:lstStyle/>
           <a:p>
             <a:pPr algn="ctr">
-              <a:defRPr sz="2000" b="1">
+              <a:defRPr sz="2400" b="1">
                 <a:solidFill>
                   <a:srgbClr val="38BDF8"/>
                 </a:solidFill>
@@ -8444,7 +8444,7 @@
               <a:spcBef>
                 <a:spcPts val="800"/>
               </a:spcBef>
-              <a:defRPr sz="1400" b="1">
+              <a:defRPr sz="1600" b="1">
                 <a:solidFill>
                   <a:srgbClr val="FFFFFF"/>
                 </a:solidFill>
@@ -8459,7 +8459,7 @@
               <a:spcBef>
                 <a:spcPts val="1200"/>
               </a:spcBef>
-              <a:defRPr sz="1100">
+              <a:defRPr sz="1250">
                 <a:solidFill>
                   <a:srgbClr val="F1F5F9"/>
                 </a:solidFill>
@@ -8479,8 +8479,8 @@
         </p:nvSpPr>
         <p:spPr>
           <a:xfrm>
-            <a:off x="6126480" y="1645920"/>
-            <a:ext cx="2514600" cy="4389120"/>
+            <a:off x="6126480" y="1600200"/>
+            <a:ext cx="2514600" cy="4480560"/>
           </a:xfrm>
           <a:prstGeom prst="roundRect">
             <a:avLst/>
@@ -8513,7 +8513,7 @@
           <a:lstStyle/>
           <a:p>
             <a:pPr algn="ctr">
-              <a:defRPr sz="2000" b="1">
+              <a:defRPr sz="2400" b="1">
                 <a:solidFill>
                   <a:srgbClr val="C084FC"/>
                 </a:solidFill>
@@ -8528,7 +8528,7 @@
               <a:spcBef>
                 <a:spcPts val="800"/>
               </a:spcBef>
-              <a:defRPr sz="1400" b="1">
+              <a:defRPr sz="1600" b="1">
                 <a:solidFill>
                   <a:srgbClr val="FFFFFF"/>
                 </a:solidFill>
@@ -8543,7 +8543,7 @@
               <a:spcBef>
                 <a:spcPts val="1200"/>
               </a:spcBef>
-              <a:defRPr sz="1100">
+              <a:defRPr sz="1250">
                 <a:solidFill>
                   <a:srgbClr val="F1F5F9"/>
                 </a:solidFill>
@@ -8563,8 +8563,8 @@
         </p:nvSpPr>
         <p:spPr>
           <a:xfrm>
-            <a:off x="8823960" y="1645920"/>
-            <a:ext cx="2514600" cy="4389120"/>
+            <a:off x="8823960" y="1600200"/>
+            <a:ext cx="2514600" cy="4480560"/>
           </a:xfrm>
           <a:prstGeom prst="roundRect">
             <a:avLst/>
@@ -8597,7 +8597,7 @@
           <a:lstStyle/>
           <a:p>
             <a:pPr algn="ctr">
-              <a:defRPr sz="2000" b="1">
+              <a:defRPr sz="2400" b="1">
                 <a:solidFill>
                   <a:srgbClr val="FBBF24"/>
                 </a:solidFill>
@@ -8612,14 +8612,14 @@
               <a:spcBef>
                 <a:spcPts val="800"/>
               </a:spcBef>
-              <a:defRPr sz="1400" b="1">
+              <a:defRPr sz="1600" b="1">
                 <a:solidFill>
                   <a:srgbClr val="FFFFFF"/>
                 </a:solidFill>
               </a:defRPr>
             </a:pPr>
             <a:r>
-              <a:t>Quality &amp; Burndown</a:t>
+              <a:t>Quality &amp; Velocity</a:t>
             </a:r>
           </a:p>
           <a:p>
@@ -8627,14 +8627,14 @@
               <a:spcBef>
                 <a:spcPts val="1200"/>
               </a:spcBef>
-              <a:defRPr sz="1100">
+              <a:defRPr sz="1250">
                 <a:solidFill>
                   <a:srgbClr val="F1F5F9"/>
                 </a:solidFill>
               </a:defRPr>
             </a:pPr>
             <a:r>
-              <a:t>Monitored velocity, enforced zero build/lint errors (npm run build), and validated 100% route health.</a:t>
+              <a:t>Monitored burndown, enforced zero build/lint errors (npm run build), and validated 100% route health.</a:t>
             </a:r>
           </a:p>
         </p:txBody>
@@ -8713,8 +8713,8 @@
         </p:nvSpPr>
         <p:spPr>
           <a:xfrm>
-            <a:off x="731520" y="365760"/>
-            <a:ext cx="5943600" cy="292608"/>
+            <a:off x="731520" y="320040"/>
+            <a:ext cx="6217920" cy="320040"/>
           </a:xfrm>
           <a:prstGeom prst="roundRect">
             <a:avLst/>
@@ -8743,11 +8743,11 @@
           </a:fontRef>
         </p:style>
         <p:txBody>
-          <a:bodyPr rtlCol="0" anchor="ctr" tIns="18288" lIns="137160"/>
+          <a:bodyPr rtlCol="0" anchor="ctr" tIns="36576" lIns="164592"/>
           <a:lstStyle/>
           <a:p>
             <a:pPr algn="ctr">
-              <a:defRPr sz="950" b="1">
+              <a:defRPr sz="1050" b="1">
                 <a:solidFill>
                   <a:srgbClr val="34D399"/>
                 </a:solidFill>
@@ -8767,8 +8767,8 @@
         </p:nvSpPr>
         <p:spPr>
           <a:xfrm>
-            <a:off x="731520" y="685800"/>
-            <a:ext cx="9601200" cy="731520"/>
+            <a:off x="731520" y="658368"/>
+            <a:ext cx="9601200" cy="777240"/>
           </a:xfrm>
           <a:prstGeom prst="rect">
             <a:avLst/>
@@ -8782,7 +8782,7 @@
           <a:lstStyle/>
           <a:p>
             <a:pPr>
-              <a:defRPr sz="2200" b="1">
+              <a:defRPr sz="2300" b="1">
                 <a:solidFill>
                   <a:srgbClr val="FFFFFF"/>
                 </a:solidFill>
@@ -8802,8 +8802,8 @@
         </p:nvSpPr>
         <p:spPr>
           <a:xfrm>
-            <a:off x="10607040" y="365760"/>
-            <a:ext cx="822960" cy="292608"/>
+            <a:off x="10515600" y="320040"/>
+            <a:ext cx="914400" cy="320040"/>
           </a:xfrm>
           <a:prstGeom prst="roundRect">
             <a:avLst/>
@@ -8832,13 +8832,13 @@
           </a:fontRef>
         </p:style>
         <p:txBody>
-          <a:bodyPr rtlCol="0" anchor="ctr" tIns="18288"/>
+          <a:bodyPr rtlCol="0" anchor="ctr" tIns="36576"/>
           <a:lstStyle/>
           <a:p>
             <a:pPr algn="ctr">
-              <a:defRPr sz="1000" b="1">
-                <a:solidFill>
-                  <a:srgbClr val="94A3B8"/>
+              <a:defRPr sz="1100" b="1">
+                <a:solidFill>
+                  <a:srgbClr val="A0AFC3"/>
                 </a:solidFill>
               </a:defRPr>
             </a:pPr>
@@ -8856,8 +8856,8 @@
         </p:nvSpPr>
         <p:spPr>
           <a:xfrm>
-            <a:off x="731520" y="1645920"/>
-            <a:ext cx="2514600" cy="4389120"/>
+            <a:off x="731520" y="1600200"/>
+            <a:ext cx="2514600" cy="4480560"/>
           </a:xfrm>
           <a:prstGeom prst="roundRect">
             <a:avLst/>
@@ -8886,11 +8886,11 @@
           </a:fontRef>
         </p:style>
         <p:txBody>
-          <a:bodyPr rtlCol="0" anchor="ctr" lIns="182880" tIns="228600" rIns="182880"/>
+          <a:bodyPr rtlCol="0" anchor="ctr" lIns="201168" tIns="228600" rIns="201168"/>
           <a:lstStyle/>
           <a:p>
             <a:pPr algn="ctr">
-              <a:defRPr sz="1100" b="1">
+              <a:defRPr sz="1200" b="1">
                 <a:solidFill>
                   <a:srgbClr val="34D399"/>
                 </a:solidFill>
@@ -8905,41 +8905,41 @@
               <a:spcBef>
                 <a:spcPts val="400"/>
               </a:spcBef>
-              <a:defRPr sz="1100" b="1">
+              <a:defRPr sz="1400" b="1">
                 <a:solidFill>
                   <a:srgbClr val="FFFFFF"/>
                 </a:solidFill>
               </a:defRPr>
             </a:pPr>
             <a:r>
-              <a:t>Architecture &amp; Database Foundations</a:t>
+              <a:t>Architecture &amp; Schema</a:t>
             </a:r>
           </a:p>
           <a:p>
             <a:pPr>
               <a:spcBef>
-                <a:spcPts val="800"/>
+                <a:spcPts val="1000"/>
               </a:spcBef>
-              <a:defRPr sz="950">
+              <a:defRPr sz="1150">
                 <a:solidFill>
                   <a:srgbClr val="F1F5F9"/>
                 </a:solidFill>
               </a:defRPr>
             </a:pPr>
             <a:r>
-              <a:t>• SRS requirements analysis &amp; schema DDL</a:t>
+              <a:t>• SRS requirements analysis</a:t>
             </a:r>
             <a:br/>
             <a:r>
-              <a:t>• RoleGuard RBAC &amp; unified login portal</a:t>
+              <a:t>• PostgreSQL schema DDL</a:t>
             </a:r>
             <a:br/>
             <a:r>
-              <a:t>• Next.js 14 App Router + Tailwind setup</a:t>
+              <a:t>• RoleGuard RBAC &amp; auth</a:t>
             </a:r>
             <a:br/>
             <a:r>
-              <a:t>• PostgreSQL seed data &amp; state schemas</a:t>
+              <a:t>• Next.js 14 + Tailwind setup</a:t>
             </a:r>
           </a:p>
         </p:txBody>
@@ -8952,8 +8952,8 @@
         </p:nvSpPr>
         <p:spPr>
           <a:xfrm>
-            <a:off x="3429000" y="1645920"/>
-            <a:ext cx="2514600" cy="4389120"/>
+            <a:off x="3429000" y="1600200"/>
+            <a:ext cx="2514600" cy="4480560"/>
           </a:xfrm>
           <a:prstGeom prst="roundRect">
             <a:avLst/>
@@ -8982,11 +8982,11 @@
           </a:fontRef>
         </p:style>
         <p:txBody>
-          <a:bodyPr rtlCol="0" anchor="ctr" lIns="182880" tIns="228600" rIns="182880"/>
+          <a:bodyPr rtlCol="0" anchor="ctr" lIns="201168" tIns="228600" rIns="201168"/>
           <a:lstStyle/>
           <a:p>
             <a:pPr algn="ctr">
-              <a:defRPr sz="1100" b="1">
+              <a:defRPr sz="1200" b="1">
                 <a:solidFill>
                   <a:srgbClr val="38BDF8"/>
                 </a:solidFill>
@@ -9001,41 +9001,41 @@
               <a:spcBef>
                 <a:spcPts val="400"/>
               </a:spcBef>
-              <a:defRPr sz="1100" b="1">
+              <a:defRPr sz="1400" b="1">
                 <a:solidFill>
                   <a:srgbClr val="FFFFFF"/>
                 </a:solidFill>
               </a:defRPr>
             </a:pPr>
             <a:r>
-              <a:t>Dynamic Slot Engine &amp; Booking</a:t>
+              <a:t>Slot Engine &amp; Booking</a:t>
             </a:r>
           </a:p>
           <a:p>
             <a:pPr>
               <a:spcBef>
-                <a:spcPts val="800"/>
+                <a:spcPts val="1000"/>
               </a:spcBef>
-              <a:defRPr sz="950">
+              <a:defRPr sz="1150">
                 <a:solidFill>
                   <a:srgbClr val="F1F5F9"/>
                 </a:solidFill>
               </a:defRPr>
             </a:pPr>
             <a:r>
-              <a:t>• Pure TypeScript slot algorithm (scheduling.ts)</a:t>
+              <a:t>• Pure TypeScript algorithm</a:t>
             </a:r>
             <a:br/>
             <a:r>
-              <a:t>• 30-min window evaluation &amp; 15-min buffers</a:t>
+              <a:t>• 30-min window evaluation</a:t>
             </a:r>
             <a:br/>
             <a:r>
-              <a:t>• 3-Step booking wizard with 20% deposit</a:t>
+              <a:t>• 15-min prep/travel buffers</a:t>
             </a:r>
             <a:br/>
             <a:r>
-              <a:t>• Concurrency locking badge (FR-03)</a:t>
+              <a:t>• 20% deposit checkout wizard</a:t>
             </a:r>
           </a:p>
         </p:txBody>
@@ -9048,8 +9048,8 @@
         </p:nvSpPr>
         <p:spPr>
           <a:xfrm>
-            <a:off x="6126480" y="1645920"/>
-            <a:ext cx="2514600" cy="4389120"/>
+            <a:off x="6126480" y="1600200"/>
+            <a:ext cx="2514600" cy="4480560"/>
           </a:xfrm>
           <a:prstGeom prst="roundRect">
             <a:avLst/>
@@ -9078,11 +9078,11 @@
           </a:fontRef>
         </p:style>
         <p:txBody>
-          <a:bodyPr rtlCol="0" anchor="ctr" lIns="182880" tIns="228600" rIns="182880"/>
+          <a:bodyPr rtlCol="0" anchor="ctr" lIns="201168" tIns="228600" rIns="201168"/>
           <a:lstStyle/>
           <a:p>
             <a:pPr algn="ctr">
-              <a:defRPr sz="1100" b="1">
+              <a:defRPr sz="1200" b="1">
                 <a:solidFill>
                   <a:srgbClr val="C084FC"/>
                 </a:solidFill>
@@ -9097,41 +9097,41 @@
               <a:spcBef>
                 <a:spcPts val="400"/>
               </a:spcBef>
-              <a:defRPr sz="1100" b="1">
+              <a:defRPr sz="1400" b="1">
                 <a:solidFill>
                   <a:srgbClr val="FFFFFF"/>
                 </a:solidFill>
               </a:defRPr>
             </a:pPr>
             <a:r>
-              <a:t>Finite State Machine &amp; Mobile</a:t>
+              <a:t>FSM &amp; Field Mobile</a:t>
             </a:r>
           </a:p>
           <a:p>
             <a:pPr>
               <a:spcBef>
-                <a:spcPts val="800"/>
+                <a:spcPts val="1000"/>
               </a:spcBef>
-              <a:defRPr sz="950">
+              <a:defRPr sz="1150">
                 <a:solidFill>
                   <a:srgbClr val="F1F5F9"/>
                 </a:solidFill>
               </a:defRPr>
             </a:pPr>
             <a:r>
-              <a:t>• Strict linear FSM engine (state-machine.ts)</a:t>
+              <a:t>• Linear FSM state validator</a:t>
             </a:r>
             <a:br/>
             <a:r>
-              <a:t>• 6-Column Operations Dispatch Kanban</a:t>
+              <a:t>• 6-Column Dispatch Kanban</a:t>
             </a:r>
             <a:br/>
             <a:r>
-              <a:t>• Skill-based staff assignment &amp; Dhaka zones</a:t>
+              <a:t>• Skill &amp; zone staff matching</a:t>
             </a:r>
             <a:br/>
             <a:r>
-              <a:t>• 390px Mobile portal + Signature pad</a:t>
+              <a:t>• 390px Mobile + Signature</a:t>
             </a:r>
           </a:p>
         </p:txBody>
@@ -9144,8 +9144,8 @@
         </p:nvSpPr>
         <p:spPr>
           <a:xfrm>
-            <a:off x="8823960" y="1645920"/>
-            <a:ext cx="2514600" cy="4389120"/>
+            <a:off x="8823960" y="1600200"/>
+            <a:ext cx="2514600" cy="4480560"/>
           </a:xfrm>
           <a:prstGeom prst="roundRect">
             <a:avLst/>
@@ -9174,11 +9174,11 @@
           </a:fontRef>
         </p:style>
         <p:txBody>
-          <a:bodyPr rtlCol="0" anchor="ctr" lIns="182880" tIns="228600" rIns="182880"/>
+          <a:bodyPr rtlCol="0" anchor="ctr" lIns="201168" tIns="228600" rIns="201168"/>
           <a:lstStyle/>
           <a:p>
             <a:pPr algn="ctr">
-              <a:defRPr sz="1100" b="1">
+              <a:defRPr sz="1200" b="1">
                 <a:solidFill>
                   <a:srgbClr val="FBBF24"/>
                 </a:solidFill>
@@ -9193,41 +9193,41 @@
               <a:spcBef>
                 <a:spcPts val="400"/>
               </a:spcBef>
-              <a:defRPr sz="1100" b="1">
+              <a:defRPr sz="1400" b="1">
                 <a:solidFill>
                   <a:srgbClr val="FFFFFF"/>
                 </a:solidFill>
               </a:defRPr>
             </a:pPr>
             <a:r>
-              <a:t>CRM Webhooks &amp; Analytics</a:t>
+              <a:t>CRM &amp; Invoicing</a:t>
             </a:r>
           </a:p>
           <a:p>
             <a:pPr>
               <a:spcBef>
-                <a:spcPts val="800"/>
+                <a:spcPts val="1000"/>
               </a:spcBef>
-              <a:defRPr sz="950">
+              <a:defRPr sz="1150">
                 <a:solidFill>
                   <a:srgbClr val="F1F5F9"/>
                 </a:solidFill>
               </a:defRPr>
             </a:pPr>
             <a:r>
-              <a:t>• Automated CRM SMS/WhatsApp alert stream</a:t>
+              <a:t>• Automated CRM alert stream</a:t>
             </a:r>
             <a:br/>
             <a:r>
-              <a:t>• Autonomous tax invoicing modal (INV-...)</a:t>
+              <a:t>• Autonomous tax invoicing</a:t>
             </a:r>
             <a:br/>
             <a:r>
-              <a:t>• Revenue &amp; Technician Productivity metrics</a:t>
+              <a:t>• Revenue &amp; CSAT analytics</a:t>
             </a:r>
             <a:br/>
             <a:r>
-              <a:t>• Production build verification (npm run build)</a:t>
+              <a:t>• Production build verification</a:t>
             </a:r>
           </a:p>
         </p:txBody>
@@ -9306,8 +9306,8 @@
         </p:nvSpPr>
         <p:spPr>
           <a:xfrm>
-            <a:off x="731520" y="365760"/>
-            <a:ext cx="5943600" cy="292608"/>
+            <a:off x="731520" y="320040"/>
+            <a:ext cx="6217920" cy="320040"/>
           </a:xfrm>
           <a:prstGeom prst="roundRect">
             <a:avLst/>
@@ -9336,11 +9336,11 @@
           </a:fontRef>
         </p:style>
         <p:txBody>
-          <a:bodyPr rtlCol="0" anchor="ctr" tIns="18288" lIns="137160"/>
+          <a:bodyPr rtlCol="0" anchor="ctr" tIns="36576" lIns="164592"/>
           <a:lstStyle/>
           <a:p>
             <a:pPr algn="ctr">
-              <a:defRPr sz="950" b="1">
+              <a:defRPr sz="1050" b="1">
                 <a:solidFill>
                   <a:srgbClr val="34D399"/>
                 </a:solidFill>
@@ -9360,8 +9360,8 @@
         </p:nvSpPr>
         <p:spPr>
           <a:xfrm>
-            <a:off x="731520" y="685800"/>
-            <a:ext cx="9601200" cy="731520"/>
+            <a:off x="731520" y="658368"/>
+            <a:ext cx="9601200" cy="777240"/>
           </a:xfrm>
           <a:prstGeom prst="rect">
             <a:avLst/>
@@ -9375,14 +9375,14 @@
           <a:lstStyle/>
           <a:p>
             <a:pPr>
-              <a:defRPr sz="2200" b="1">
+              <a:defRPr sz="2300" b="1">
                 <a:solidFill>
                   <a:srgbClr val="FFFFFF"/>
                 </a:solidFill>
               </a:defRPr>
             </a:pPr>
             <a:r>
-              <a:t>Feature 1: Intelligent Dynamic Slot Engine &amp; Concurrency Locking</a:t>
+              <a:t>Feature 1: Dynamic Slot Engine &amp; Concurrency Locking</a:t>
             </a:r>
           </a:p>
         </p:txBody>
@@ -9395,8 +9395,8 @@
         </p:nvSpPr>
         <p:spPr>
           <a:xfrm>
-            <a:off x="10607040" y="365760"/>
-            <a:ext cx="822960" cy="292608"/>
+            <a:off x="10515600" y="320040"/>
+            <a:ext cx="914400" cy="320040"/>
           </a:xfrm>
           <a:prstGeom prst="roundRect">
             <a:avLst/>
@@ -9425,13 +9425,13 @@
           </a:fontRef>
         </p:style>
         <p:txBody>
-          <a:bodyPr rtlCol="0" anchor="ctr" tIns="18288"/>
+          <a:bodyPr rtlCol="0" anchor="ctr" tIns="36576"/>
           <a:lstStyle/>
           <a:p>
             <a:pPr algn="ctr">
-              <a:defRPr sz="1000" b="1">
-                <a:solidFill>
-                  <a:srgbClr val="94A3B8"/>
+              <a:defRPr sz="1100" b="1">
+                <a:solidFill>
+                  <a:srgbClr val="A0AFC3"/>
                 </a:solidFill>
               </a:defRPr>
             </a:pPr>
@@ -9449,8 +9449,8 @@
         </p:nvSpPr>
         <p:spPr>
           <a:xfrm>
-            <a:off x="731520" y="1645920"/>
-            <a:ext cx="5166360" cy="4389120"/>
+            <a:off x="731520" y="1600200"/>
+            <a:ext cx="5166360" cy="4480560"/>
           </a:xfrm>
           <a:prstGeom prst="roundRect">
             <a:avLst/>
@@ -9479,11 +9479,11 @@
           </a:fontRef>
         </p:style>
         <p:txBody>
-          <a:bodyPr rtlCol="0" anchor="ctr" lIns="274320" tIns="274320"/>
+          <a:bodyPr rtlCol="0" anchor="ctr" lIns="320040" tIns="274320"/>
           <a:lstStyle/>
           <a:p>
             <a:pPr algn="ctr">
-              <a:defRPr sz="1400" b="1">
+              <a:defRPr sz="1650" b="1">
                 <a:solidFill>
                   <a:srgbClr val="34D399"/>
                 </a:solidFill>
@@ -9496,9 +9496,9 @@
           <a:p>
             <a:pPr>
               <a:spcBef>
-                <a:spcPts val="1000"/>
+                <a:spcPts val="1200"/>
               </a:spcBef>
-              <a:defRPr sz="1100">
+              <a:defRPr sz="1300">
                 <a:solidFill>
                   <a:srgbClr val="F1F5F9"/>
                 </a:solidFill>
@@ -9538,8 +9538,8 @@
         </p:nvSpPr>
         <p:spPr>
           <a:xfrm>
-            <a:off x="6217920" y="1645920"/>
-            <a:ext cx="5212080" cy="4389120"/>
+            <a:off x="6217920" y="1600200"/>
+            <a:ext cx="5212080" cy="4480560"/>
           </a:xfrm>
           <a:prstGeom prst="roundRect">
             <a:avLst/>
@@ -9568,11 +9568,11 @@
           </a:fontRef>
         </p:style>
         <p:txBody>
-          <a:bodyPr rtlCol="0" anchor="ctr" lIns="274320" tIns="274320"/>
+          <a:bodyPr rtlCol="0" anchor="ctr" lIns="320040" tIns="274320"/>
           <a:lstStyle/>
           <a:p>
             <a:pPr algn="ctr">
-              <a:defRPr sz="1400" b="1">
+              <a:defRPr sz="1650" b="1">
                 <a:solidFill>
                   <a:srgbClr val="38BDF8"/>
                 </a:solidFill>
@@ -9585,9 +9585,9 @@
           <a:p>
             <a:pPr>
               <a:spcBef>
-                <a:spcPts val="1000"/>
+                <a:spcPts val="1200"/>
               </a:spcBef>
-              <a:defRPr sz="1100">
+              <a:defRPr sz="1300">
                 <a:solidFill>
                   <a:srgbClr val="F1F5F9"/>
                 </a:solidFill>
@@ -9598,7 +9598,7 @@
             </a:r>
             <a:br/>
             <a:r>
-              <a:t>• Database transactional locking eliminates double-booking collisions</a:t>
+              <a:t>• Database transactional locking eliminates race conditions</a:t>
             </a:r>
             <a:br/>
             <a:r>
@@ -9606,7 +9606,7 @@
             </a:r>
             <a:br/>
             <a:r>
-              <a:t>• Eliminates customer no-shows through financial commitment</a:t>
+              <a:t>• Eliminates customer no-shows through financial lock</a:t>
             </a:r>
             <a:br/>
             <a:r>
@@ -9689,8 +9689,8 @@
         </p:nvSpPr>
         <p:spPr>
           <a:xfrm>
-            <a:off x="731520" y="365760"/>
-            <a:ext cx="5943600" cy="292608"/>
+            <a:off x="731520" y="320040"/>
+            <a:ext cx="6217920" cy="320040"/>
           </a:xfrm>
           <a:prstGeom prst="roundRect">
             <a:avLst/>
@@ -9719,11 +9719,11 @@
           </a:fontRef>
         </p:style>
         <p:txBody>
-          <a:bodyPr rtlCol="0" anchor="ctr" tIns="18288" lIns="137160"/>
+          <a:bodyPr rtlCol="0" anchor="ctr" tIns="36576" lIns="164592"/>
           <a:lstStyle/>
           <a:p>
             <a:pPr algn="ctr">
-              <a:defRPr sz="950" b="1">
+              <a:defRPr sz="1050" b="1">
                 <a:solidFill>
                   <a:srgbClr val="34D399"/>
                 </a:solidFill>
@@ -9743,8 +9743,8 @@
         </p:nvSpPr>
         <p:spPr>
           <a:xfrm>
-            <a:off x="731520" y="685800"/>
-            <a:ext cx="9601200" cy="731520"/>
+            <a:off x="731520" y="658368"/>
+            <a:ext cx="9601200" cy="777240"/>
           </a:xfrm>
           <a:prstGeom prst="rect">
             <a:avLst/>
@@ -9758,7 +9758,7 @@
           <a:lstStyle/>
           <a:p>
             <a:pPr>
-              <a:defRPr sz="2200" b="1">
+              <a:defRPr sz="2300" b="1">
                 <a:solidFill>
                   <a:srgbClr val="FFFFFF"/>
                 </a:solidFill>
@@ -9778,8 +9778,8 @@
         </p:nvSpPr>
         <p:spPr>
           <a:xfrm>
-            <a:off x="10607040" y="365760"/>
-            <a:ext cx="822960" cy="292608"/>
+            <a:off x="10515600" y="320040"/>
+            <a:ext cx="914400" cy="320040"/>
           </a:xfrm>
           <a:prstGeom prst="roundRect">
             <a:avLst/>
@@ -9808,13 +9808,13 @@
           </a:fontRef>
         </p:style>
         <p:txBody>
-          <a:bodyPr rtlCol="0" anchor="ctr" tIns="18288"/>
+          <a:bodyPr rtlCol="0" anchor="ctr" tIns="36576"/>
           <a:lstStyle/>
           <a:p>
             <a:pPr algn="ctr">
-              <a:defRPr sz="1000" b="1">
-                <a:solidFill>
-                  <a:srgbClr val="94A3B8"/>
+              <a:defRPr sz="1100" b="1">
+                <a:solidFill>
+                  <a:srgbClr val="A0AFC3"/>
                 </a:solidFill>
               </a:defRPr>
             </a:pPr>
@@ -9832,8 +9832,8 @@
         </p:nvSpPr>
         <p:spPr>
           <a:xfrm>
-            <a:off x="731520" y="1645920"/>
-            <a:ext cx="1645920" cy="4389120"/>
+            <a:off x="731520" y="1600200"/>
+            <a:ext cx="1645920" cy="4480560"/>
           </a:xfrm>
           <a:prstGeom prst="roundRect">
             <a:avLst/>
@@ -9866,7 +9866,7 @@
           <a:lstStyle/>
           <a:p>
             <a:pPr algn="ctr">
-              <a:defRPr sz="950" b="1">
+              <a:defRPr sz="1100" b="1">
                 <a:solidFill>
                   <a:srgbClr val="38BDF8"/>
                 </a:solidFill>
@@ -9881,7 +9881,7 @@
               <a:spcBef>
                 <a:spcPts val="400"/>
               </a:spcBef>
-              <a:defRPr sz="1200" b="1">
+              <a:defRPr sz="1400" b="1">
                 <a:solidFill>
                   <a:srgbClr val="FFFFFF"/>
                 </a:solidFill>
@@ -9896,7 +9896,7 @@
               <a:spcBef>
                 <a:spcPts val="800"/>
               </a:spcBef>
-              <a:defRPr sz="950" b="1">
+              <a:defRPr sz="1100" b="1">
                 <a:solidFill>
                   <a:srgbClr val="38BDF8"/>
                 </a:solidFill>
@@ -9911,9 +9911,9 @@
               <a:spcBef>
                 <a:spcPts val="800"/>
               </a:spcBef>
-              <a:defRPr sz="950">
-                <a:solidFill>
-                  <a:srgbClr val="94A3B8"/>
+              <a:defRPr sz="1100">
+                <a:solidFill>
+                  <a:srgbClr val="F1F5F9"/>
                 </a:solidFill>
               </a:defRPr>
             </a:pPr>
@@ -9931,8 +9931,8 @@
         </p:nvSpPr>
         <p:spPr>
           <a:xfrm>
-            <a:off x="2514600" y="1645920"/>
-            <a:ext cx="1645920" cy="4389120"/>
+            <a:off x="2514600" y="1600200"/>
+            <a:ext cx="1645920" cy="4480560"/>
           </a:xfrm>
           <a:prstGeom prst="roundRect">
             <a:avLst/>
@@ -9965,7 +9965,7 @@
           <a:lstStyle/>
           <a:p>
             <a:pPr algn="ctr">
-              <a:defRPr sz="950" b="1">
+              <a:defRPr sz="1100" b="1">
                 <a:solidFill>
                   <a:srgbClr val="C084FC"/>
                 </a:solidFill>
@@ -9980,7 +9980,7 @@
               <a:spcBef>
                 <a:spcPts val="400"/>
               </a:spcBef>
-              <a:defRPr sz="1200" b="1">
+              <a:defRPr sz="1400" b="1">
                 <a:solidFill>
                   <a:srgbClr val="FFFFFF"/>
                 </a:solidFill>
@@ -9995,7 +9995,7 @@
               <a:spcBef>
                 <a:spcPts val="800"/>
               </a:spcBef>
-              <a:defRPr sz="950" b="1">
+              <a:defRPr sz="1100" b="1">
                 <a:solidFill>
                   <a:srgbClr val="38BDF8"/>
                 </a:solidFill>
@@ -10010,9 +10010,9 @@
               <a:spcBef>
                 <a:spcPts val="800"/>
               </a:spcBef>
-              <a:defRPr sz="950">
-                <a:solidFill>
-                  <a:srgbClr val="94A3B8"/>
+              <a:defRPr sz="1100">
+                <a:solidFill>
+                  <a:srgbClr val="F1F5F9"/>
                 </a:solidFill>
               </a:defRPr>
             </a:pPr>
@@ -10030,8 +10030,8 @@
         </p:nvSpPr>
         <p:spPr>
           <a:xfrm>
-            <a:off x="4297680" y="1645920"/>
-            <a:ext cx="1645920" cy="4389120"/>
+            <a:off x="4297680" y="1600200"/>
+            <a:ext cx="1645920" cy="4480560"/>
           </a:xfrm>
           <a:prstGeom prst="roundRect">
             <a:avLst/>
@@ -10064,7 +10064,7 @@
           <a:lstStyle/>
           <a:p>
             <a:pPr algn="ctr">
-              <a:defRPr sz="950" b="1">
+              <a:defRPr sz="1100" b="1">
                 <a:solidFill>
                   <a:srgbClr val="FBBF24"/>
                 </a:solidFill>
@@ -10079,7 +10079,7 @@
               <a:spcBef>
                 <a:spcPts val="400"/>
               </a:spcBef>
-              <a:defRPr sz="1200" b="1">
+              <a:defRPr sz="1400" b="1">
                 <a:solidFill>
                   <a:srgbClr val="FFFFFF"/>
                 </a:solidFill>
@@ -10094,7 +10094,7 @@
               <a:spcBef>
                 <a:spcPts val="800"/>
               </a:spcBef>
-              <a:defRPr sz="950" b="1">
+              <a:defRPr sz="1100" b="1">
                 <a:solidFill>
                   <a:srgbClr val="38BDF8"/>
                 </a:solidFill>
@@ -10109,9 +10109,9 @@
               <a:spcBef>
                 <a:spcPts val="800"/>
               </a:spcBef>
-              <a:defRPr sz="950">
-                <a:solidFill>
-                  <a:srgbClr val="94A3B8"/>
+              <a:defRPr sz="1100">
+                <a:solidFill>
+                  <a:srgbClr val="F1F5F9"/>
                 </a:solidFill>
               </a:defRPr>
             </a:pPr>
@@ -10129,8 +10129,8 @@
         </p:nvSpPr>
         <p:spPr>
           <a:xfrm>
-            <a:off x="6080759" y="1645920"/>
-            <a:ext cx="1645920" cy="4389120"/>
+            <a:off x="6080759" y="1600200"/>
+            <a:ext cx="1645920" cy="4480560"/>
           </a:xfrm>
           <a:prstGeom prst="roundRect">
             <a:avLst/>
@@ -10163,7 +10163,7 @@
           <a:lstStyle/>
           <a:p>
             <a:pPr algn="ctr">
-              <a:defRPr sz="950" b="1">
+              <a:defRPr sz="1100" b="1">
                 <a:solidFill>
                   <a:srgbClr val="34D399"/>
                 </a:solidFill>
@@ -10178,7 +10178,7 @@
               <a:spcBef>
                 <a:spcPts val="400"/>
               </a:spcBef>
-              <a:defRPr sz="1200" b="1">
+              <a:defRPr sz="1400" b="1">
                 <a:solidFill>
                   <a:srgbClr val="FFFFFF"/>
                 </a:solidFill>
@@ -10193,7 +10193,7 @@
               <a:spcBef>
                 <a:spcPts val="800"/>
               </a:spcBef>
-              <a:defRPr sz="950" b="1">
+              <a:defRPr sz="1100" b="1">
                 <a:solidFill>
                   <a:srgbClr val="38BDF8"/>
                 </a:solidFill>
@@ -10208,9 +10208,9 @@
               <a:spcBef>
                 <a:spcPts val="800"/>
               </a:spcBef>
-              <a:defRPr sz="950">
-                <a:solidFill>
-                  <a:srgbClr val="94A3B8"/>
+              <a:defRPr sz="1100">
+                <a:solidFill>
+                  <a:srgbClr val="F1F5F9"/>
                 </a:solidFill>
               </a:defRPr>
             </a:pPr>
@@ -10228,8 +10228,8 @@
         </p:nvSpPr>
         <p:spPr>
           <a:xfrm>
-            <a:off x="7863840" y="1645920"/>
-            <a:ext cx="1645920" cy="4389120"/>
+            <a:off x="7863840" y="1600200"/>
+            <a:ext cx="1645920" cy="4480560"/>
           </a:xfrm>
           <a:prstGeom prst="roundRect">
             <a:avLst/>
@@ -10262,7 +10262,7 @@
           <a:lstStyle/>
           <a:p>
             <a:pPr algn="ctr">
-              <a:defRPr sz="950" b="1">
+              <a:defRPr sz="1100" b="1">
                 <a:solidFill>
                   <a:srgbClr val="38BDF8"/>
                 </a:solidFill>
@@ -10277,7 +10277,7 @@
               <a:spcBef>
                 <a:spcPts val="400"/>
               </a:spcBef>
-              <a:defRPr sz="1200" b="1">
+              <a:defRPr sz="1400" b="1">
                 <a:solidFill>
                   <a:srgbClr val="FFFFFF"/>
                 </a:solidFill>
@@ -10292,7 +10292,7 @@
               <a:spcBef>
                 <a:spcPts val="800"/>
               </a:spcBef>
-              <a:defRPr sz="950" b="1">
+              <a:defRPr sz="1100" b="1">
                 <a:solidFill>
                   <a:srgbClr val="38BDF8"/>
                 </a:solidFill>
@@ -10307,9 +10307,9 @@
               <a:spcBef>
                 <a:spcPts val="800"/>
               </a:spcBef>
-              <a:defRPr sz="950">
-                <a:solidFill>
-                  <a:srgbClr val="94A3B8"/>
+              <a:defRPr sz="1100">
+                <a:solidFill>
+                  <a:srgbClr val="F1F5F9"/>
                 </a:solidFill>
               </a:defRPr>
             </a:pPr>
@@ -10327,8 +10327,8 @@
         </p:nvSpPr>
         <p:spPr>
           <a:xfrm>
-            <a:off x="9646920" y="1645920"/>
-            <a:ext cx="1645920" cy="4389120"/>
+            <a:off x="9646920" y="1600200"/>
+            <a:ext cx="1645920" cy="4480560"/>
           </a:xfrm>
           <a:prstGeom prst="roundRect">
             <a:avLst/>
@@ -10361,7 +10361,7 @@
           <a:lstStyle/>
           <a:p>
             <a:pPr algn="ctr">
-              <a:defRPr sz="950" b="1">
+              <a:defRPr sz="1100" b="1">
                 <a:solidFill>
                   <a:srgbClr val="34D399"/>
                 </a:solidFill>
@@ -10376,7 +10376,7 @@
               <a:spcBef>
                 <a:spcPts val="400"/>
               </a:spcBef>
-              <a:defRPr sz="1200" b="1">
+              <a:defRPr sz="1400" b="1">
                 <a:solidFill>
                   <a:srgbClr val="FFFFFF"/>
                 </a:solidFill>
@@ -10391,7 +10391,7 @@
               <a:spcBef>
                 <a:spcPts val="800"/>
               </a:spcBef>
-              <a:defRPr sz="950" b="1">
+              <a:defRPr sz="1100" b="1">
                 <a:solidFill>
                   <a:srgbClr val="38BDF8"/>
                 </a:solidFill>
@@ -10406,9 +10406,9 @@
               <a:spcBef>
                 <a:spcPts val="800"/>
               </a:spcBef>
-              <a:defRPr sz="950">
-                <a:solidFill>
-                  <a:srgbClr val="94A3B8"/>
+              <a:defRPr sz="1100">
+                <a:solidFill>
+                  <a:srgbClr val="F1F5F9"/>
                 </a:solidFill>
               </a:defRPr>
             </a:pPr>
@@ -10492,8 +10492,8 @@
         </p:nvSpPr>
         <p:spPr>
           <a:xfrm>
-            <a:off x="731520" y="365760"/>
-            <a:ext cx="5943600" cy="292608"/>
+            <a:off x="731520" y="320040"/>
+            <a:ext cx="6217920" cy="320040"/>
           </a:xfrm>
           <a:prstGeom prst="roundRect">
             <a:avLst/>
@@ -10522,11 +10522,11 @@
           </a:fontRef>
         </p:style>
         <p:txBody>
-          <a:bodyPr rtlCol="0" anchor="ctr" tIns="18288" lIns="137160"/>
+          <a:bodyPr rtlCol="0" anchor="ctr" tIns="36576" lIns="164592"/>
           <a:lstStyle/>
           <a:p>
             <a:pPr algn="ctr">
-              <a:defRPr sz="950" b="1">
+              <a:defRPr sz="1050" b="1">
                 <a:solidFill>
                   <a:srgbClr val="34D399"/>
                 </a:solidFill>
@@ -10546,8 +10546,8 @@
         </p:nvSpPr>
         <p:spPr>
           <a:xfrm>
-            <a:off x="731520" y="685800"/>
-            <a:ext cx="9601200" cy="731520"/>
+            <a:off x="731520" y="658368"/>
+            <a:ext cx="9601200" cy="777240"/>
           </a:xfrm>
           <a:prstGeom prst="rect">
             <a:avLst/>
@@ -10561,7 +10561,7 @@
           <a:lstStyle/>
           <a:p>
             <a:pPr>
-              <a:defRPr sz="2200" b="1">
+              <a:defRPr sz="2300" b="1">
                 <a:solidFill>
                   <a:srgbClr val="FFFFFF"/>
                 </a:solidFill>
@@ -10581,8 +10581,8 @@
         </p:nvSpPr>
         <p:spPr>
           <a:xfrm>
-            <a:off x="10607040" y="365760"/>
-            <a:ext cx="822960" cy="292608"/>
+            <a:off x="10515600" y="320040"/>
+            <a:ext cx="914400" cy="320040"/>
           </a:xfrm>
           <a:prstGeom prst="roundRect">
             <a:avLst/>
@@ -10611,13 +10611,13 @@
           </a:fontRef>
         </p:style>
         <p:txBody>
-          <a:bodyPr rtlCol="0" anchor="ctr" tIns="18288"/>
+          <a:bodyPr rtlCol="0" anchor="ctr" tIns="36576"/>
           <a:lstStyle/>
           <a:p>
             <a:pPr algn="ctr">
-              <a:defRPr sz="1000" b="1">
-                <a:solidFill>
-                  <a:srgbClr val="94A3B8"/>
+              <a:defRPr sz="1100" b="1">
+                <a:solidFill>
+                  <a:srgbClr val="A0AFC3"/>
                 </a:solidFill>
               </a:defRPr>
             </a:pPr>
@@ -10635,8 +10635,8 @@
         </p:nvSpPr>
         <p:spPr>
           <a:xfrm>
-            <a:off x="731520" y="1645920"/>
-            <a:ext cx="5166360" cy="4389120"/>
+            <a:off x="731520" y="1600200"/>
+            <a:ext cx="5166360" cy="4480560"/>
           </a:xfrm>
           <a:prstGeom prst="roundRect">
             <a:avLst/>
@@ -10665,11 +10665,11 @@
           </a:fontRef>
         </p:style>
         <p:txBody>
-          <a:bodyPr rtlCol="0" anchor="ctr" lIns="274320" tIns="274320"/>
+          <a:bodyPr rtlCol="0" anchor="ctr" lIns="320040" tIns="274320"/>
           <a:lstStyle/>
           <a:p>
             <a:pPr algn="ctr">
-              <a:defRPr sz="1400" b="1">
+              <a:defRPr sz="1650" b="1">
                 <a:solidFill>
                   <a:srgbClr val="C084FC"/>
                 </a:solidFill>
@@ -10682,9 +10682,9 @@
           <a:p>
             <a:pPr>
               <a:spcBef>
-                <a:spcPts val="1000"/>
+                <a:spcPts val="1200"/>
               </a:spcBef>
-              <a:defRPr sz="1100">
+              <a:defRPr sz="1300">
                 <a:solidFill>
                   <a:srgbClr val="F1F5F9"/>
                 </a:solidFill>
@@ -10695,7 +10695,7 @@
             </a:r>
             <a:br/>
             <a:r>
-              <a:t>• Technician skill taxonomy (Paint Buffing, Steam Sanitization, Diagnostics)</a:t>
+              <a:t>• Technician skill taxonomy (Paint Buffing, Steam Sanitization)</a:t>
             </a:r>
             <a:br/>
             <a:r>
@@ -10703,7 +10703,7 @@
             </a:r>
             <a:br/>
             <a:r>
-              <a:t>• Geographical zone proximity routing (Gulshan / Banani / Dhanmondi)</a:t>
+              <a:t>• Geographical zone proximity routing (Gulshan / Banani)</a:t>
             </a:r>
             <a:br/>
             <a:r>
@@ -10720,8 +10720,8 @@
         </p:nvSpPr>
         <p:spPr>
           <a:xfrm>
-            <a:off x="6217920" y="1645920"/>
-            <a:ext cx="5212080" cy="4389120"/>
+            <a:off x="6217920" y="1600200"/>
+            <a:ext cx="5212080" cy="4480560"/>
           </a:xfrm>
           <a:prstGeom prst="roundRect">
             <a:avLst/>
@@ -10750,11 +10750,11 @@
           </a:fontRef>
         </p:style>
         <p:txBody>
-          <a:bodyPr rtlCol="0" anchor="ctr" lIns="274320" tIns="274320"/>
+          <a:bodyPr rtlCol="0" anchor="ctr" lIns="320040" tIns="274320"/>
           <a:lstStyle/>
           <a:p>
             <a:pPr algn="ctr">
-              <a:defRPr sz="1400" b="1">
+              <a:defRPr sz="1650" b="1">
                 <a:solidFill>
                   <a:srgbClr val="38BDF8"/>
                 </a:solidFill>
@@ -10767,16 +10767,16 @@
           <a:p>
             <a:pPr>
               <a:spcBef>
-                <a:spcPts val="1000"/>
+                <a:spcPts val="1200"/>
               </a:spcBef>
-              <a:defRPr sz="1100">
+              <a:defRPr sz="1300">
                 <a:solidFill>
                   <a:srgbClr val="F1F5F9"/>
                 </a:solidFill>
               </a:defRPr>
             </a:pPr>
             <a:r>
-              <a:t>• 390px mobile viewport frame with minimal wireframe aesthetics</a:t>
+              <a:t>• 390px mobile viewport frame with minimal wireframe styling</a:t>
             </a:r>
             <a:br/>
             <a:r>
@@ -10784,7 +10784,7 @@
             </a:r>
             <a:br/>
             <a:r>
-              <a:t>• 1-Tap Sequential Actions: 'Accept &amp; Start Trip' ➔ 'Arrived &amp; Start Timer'</a:t>
+              <a:t>• 1-Tap Sequential Actions: 'Accept Trip' ➔ 'Start Timer'</a:t>
             </a:r>
             <a:br/>
             <a:r>

</xml_diff>